<commit_message>
Correct the stitching-reference slide from measurement
The multichannel fluorescence set shows that the crisp nuclear channel
registers more decisively than busier channels or a merge, so the slide
no longer says to measure on the image with the most contrast. It now
says the clearest, best separated structure, which is what the data
supports.

TODO records the seam measurements, and that the extension's "Auto (most
texture)" pick would have chosen the channel that scored last.

Claude-Session: https://claude.ai/code/session_01KwiACUr5MacuDvqp74c96o
</commit_message>
<xml_diff>
--- a/I2K_2026_QuPath_Extensions.pptx
+++ b/I2K_2026_QuPath_Extensions.pptx
@@ -12392,7 +12392,7 @@
                 <a:ea typeface="Trebuchet MS" pitchFamily="34" charset="-122"/>
                 <a:cs typeface="Trebuchet MS" pitchFamily="34" charset="-120"/>
               </a:rPr>
-              <a:t>Measure once, on the image with the most contrast</a:t>
+              <a:t>Measure once, on the image with the clearest structure</a:t>
             </a:r>
             <a:endParaRPr lang="en-US" sz="3000" dirty="0"/>
           </a:p>
@@ -12577,7 +12577,7 @@
                 <a:ea typeface="Calibri" pitchFamily="34" charset="-122"/>
                 <a:cs typeface="Calibri" pitchFamily="34" charset="-120"/>
               </a:rPr>
-              <a:t>Measure the positions on whichever angle or channel carries the most information. Every other image of the same tiles reuses that measurement, so they stay aligned with each other.</a:t>
+              <a:t>Measure the positions on the image with the most distinct, best separated structure, which is not always the brightest or the busiest one. Every other image of the same tiles reuses that measurement, so they stay aligned with each other.</a:t>
             </a:r>
             <a:endParaRPr lang="en-US" sz="1500" dirty="0"/>
           </a:p>

</xml_diff>

<commit_message>
Remove claims we cannot support
Several statements asserted evidence that does not exist: "the single
most common problem we see", "the answer roughly half the time", "about
half of all reports", "saves the most support time", "the fastest
quality check available". Replaced with the mechanism, which is both
true and more useful: extensions are only loaded at startup.

The scenario figure of 467 slides appeared in four places as though it
were a measurement. It is now "a few hundred", which is what it meant.

Verified rather than cut: the Dialog Position Manager's shared-storage
claim is real (DialogPositionPreferences points several workstations at
one JSON file, and the UI says so).

Claude-Session: https://claude.ai/code/session_01KwiACUr5MacuDvqp74c96o
</commit_message>
<xml_diff>
--- a/I2K_2026_QuPath_Extensions.pptx
+++ b/I2K_2026_QuPath_Extensions.pptx
@@ -7721,7 +7721,7 @@
                 <a:ea typeface="Calibri" pitchFamily="34" charset="-122"/>
                 <a:cs typeface="Calibri" pitchFamily="34" charset="-120"/>
               </a:rPr>
-              <a:t>The least glamorous tool here, and the one that saves the most support time.</a:t>
+              <a:t>The least glamorous tool here.</a:t>
             </a:r>
             <a:endParaRPr lang="en-US" sz="1700" dirty="0"/>
           </a:p>
@@ -11493,7 +11493,7 @@
                 <a:ea typeface="Calibri" pitchFamily="34" charset="-122"/>
                 <a:cs typeface="Calibri" pitchFamily="34" charset="-120"/>
               </a:rPr>
-              <a:t>If you just ran label recognition across 467 slides, this is where you find out whether it worked.</a:t>
+              <a:t>If you just ran label recognition across a few hundred slides, this is where you find out whether it worked.</a:t>
             </a:r>
             <a:endParaRPr lang="en-US" sz="1700" dirty="0"/>
           </a:p>
@@ -11675,7 +11675,7 @@
                 <a:ea typeface="Calibri" pitchFamily="34" charset="-122"/>
                 <a:cs typeface="Calibri" pitchFamily="34" charset="-120"/>
               </a:rPr>
-              <a:t>Sorting by a recognised column is the fastest quality check available — bad reads are outliers.</a:t>
+              <a:t>Sorting by a recognised column makes the bad reads stand out as outliers.</a:t>
             </a:r>
             <a:endParaRPr lang="en-US" sz="1600" dirty="0"/>
           </a:p>

</xml_diff>

<commit_message>
Stop implying Sara's session is the same day as ours
"Runs before ours", "this morning" and "earlier today" all read as the
same day, in a session immediately before this one. It is earlier in the
conference, so the site and the deck now say that. The exact slot is
still to be confirmed, which is why the wording stays general.

Also drops "hour-by-hour" from the schedule description, since the
minute-by-minute running order was removed.

Claude-Session: https://claude.ai/code/session_01KwiACUr5MacuDvqp74c96o
</commit_message>
<xml_diff>
--- a/I2K_2026_QuPath_Extensions.pptx
+++ b/I2K_2026_QuPath_Extensions.pptx
@@ -7949,7 +7949,7 @@
                 <a:ea typeface="Trebuchet MS" pitchFamily="34" charset="-122"/>
                 <a:cs typeface="Trebuchet MS" pitchFamily="34" charset="-120"/>
               </a:rPr>
-              <a:t>Two you already saw this morning</a:t>
+              <a:t>Two you may already have seen</a:t>
             </a:r>
             <a:endParaRPr lang="en-US" sz="3000" dirty="0"/>
           </a:p>
@@ -8008,7 +8008,7 @@
                 <a:ea typeface="Calibri" pitchFamily="34" charset="-122"/>
                 <a:cs typeface="Calibri" pitchFamily="34" charset="-120"/>
               </a:rPr>
-              <a:t>From “Tips and tricks for maintaining sanity during hi-plex classification in QuPath”, earlier today.</a:t>
+              <a:t>From “Tips and tricks for maintaining sanity during hi-plex classification in QuPath”, earlier in the conference.</a:t>
             </a:r>
             <a:endParaRPr lang="en-US" sz="1700" dirty="0"/>
           </a:p>
@@ -8102,7 +8102,7 @@
                 <a:ea typeface="Calibri" pitchFamily="34" charset="-122"/>
                 <a:cs typeface="Calibri" pitchFamily="34" charset="-120"/>
               </a:rPr>
-              <a:t>Both began as Sara McArdle’s Groovy scripts, and Sara demonstrated both in the session before this one</a:t>
+              <a:t>Both began as Sara McArdle’s Groovy scripts, and Sara demonstrated both in her session earlier in the conference</a:t>
             </a:r>
             <a:endParaRPr lang="en-US" sz="2000" dirty="0"/>
           </a:p>
@@ -15538,7 +15538,7 @@
                 <a:ea typeface="Calibri" pitchFamily="34" charset="-122"/>
                 <a:cs typeface="Calibri" pitchFamily="34" charset="-120"/>
               </a:rPr>
-              <a:t>We are not re-teaching it. Sara’s session this morning was the hi-plex classification half</a:t>
+              <a:t>We are not re-teaching it. Sara’s earlier session was the hi-plex classification half</a:t>
             </a:r>
             <a:endParaRPr lang="en-US" sz="2000" dirty="0"/>
           </a:p>
@@ -19815,7 +19815,7 @@
                 <a:ea typeface="Calibri" pitchFamily="34" charset="-122"/>
                 <a:cs typeface="Calibri" pitchFamily="34" charset="-120"/>
               </a:rPr>
-              <a:t>A few slots are fixed; two more were covered in Sara McArdle’s session this morning</a:t>
+              <a:t>A few slots are fixed; two more were covered in Sara McArdle’s session earlier in the conference</a:t>
             </a:r>
             <a:endParaRPr lang="en-US" sz="2000" dirty="0"/>
           </a:p>
@@ -21604,7 +21604,7 @@
                 <a:ea typeface="Calibri" pitchFamily="34" charset="-122"/>
                 <a:cs typeface="Calibri" pitchFamily="34" charset="-120"/>
               </a:rPr>
-              <a:t>Already fixed: QPSC, the Confusion Matrix and the fibre tools are shown regardless — and Channel Names Viewer and Classify Object Subset were covered in Sara McArdle’s session this morning.
+              <a:t>Already fixed: QPSC, the Confusion Matrix and the fibre tools are shown regardless — and Channel Names Viewer and Classify Object Subset were covered in Sara McArdle’s session earlier in the conference.
 </a:t>
             </a:r>
             <a:pPr indent="0" marL="0">

</xml_diff>

<commit_message>
Name Sara's session: Monday 28 September, 11:00, DeLuca Forum
The site and deck now give the day, time and venue instead of a vague
"earlier in the conference". The schedule also no longer frames the two
as a choice: they are on different days, so attendees can go to both.

Deck wording says "yesterday" and "Monday", which is accurate when
presented on the Tuesday.

TODO: time and venue received; her session URL is still outstanding.

Claude-Session: https://claude.ai/code/session_01KwiACUr5MacuDvqp74c96o
</commit_message>
<xml_diff>
--- a/I2K_2026_QuPath_Extensions.pptx
+++ b/I2K_2026_QuPath_Extensions.pptx
@@ -8008,7 +8008,7 @@
                 <a:ea typeface="Calibri" pitchFamily="34" charset="-122"/>
                 <a:cs typeface="Calibri" pitchFamily="34" charset="-120"/>
               </a:rPr>
-              <a:t>From “Tips and tricks for maintaining sanity during hi-plex classification in QuPath”, earlier in the conference.</a:t>
+              <a:t>From “Tips and tricks for maintaining sanity during hi-plex classification in QuPath”, Monday 11:00.</a:t>
             </a:r>
             <a:endParaRPr lang="en-US" sz="1700" dirty="0"/>
           </a:p>
@@ -8102,7 +8102,7 @@
                 <a:ea typeface="Calibri" pitchFamily="34" charset="-122"/>
                 <a:cs typeface="Calibri" pitchFamily="34" charset="-120"/>
               </a:rPr>
-              <a:t>Both began as Sara McArdle’s Groovy scripts, and Sara demonstrated both in her session earlier in the conference</a:t>
+              <a:t>Both began as Sara McArdle’s Groovy scripts, and Sara demonstrated both in her session yesterday</a:t>
             </a:r>
             <a:endParaRPr lang="en-US" sz="2000" dirty="0"/>
           </a:p>
@@ -15538,7 +15538,7 @@
                 <a:ea typeface="Calibri" pitchFamily="34" charset="-122"/>
                 <a:cs typeface="Calibri" pitchFamily="34" charset="-120"/>
               </a:rPr>
-              <a:t>We are not re-teaching it. Sara’s earlier session was the hi-plex classification half</a:t>
+              <a:t>We are not re-teaching it. Sara’s Monday session was the hi-plex classification half</a:t>
             </a:r>
             <a:endParaRPr lang="en-US" sz="2000" dirty="0"/>
           </a:p>
@@ -19815,7 +19815,7 @@
                 <a:ea typeface="Calibri" pitchFamily="34" charset="-122"/>
                 <a:cs typeface="Calibri" pitchFamily="34" charset="-120"/>
               </a:rPr>
-              <a:t>A few slots are fixed; two more were covered in Sara McArdle’s session earlier in the conference</a:t>
+              <a:t>A few slots are fixed; two more were covered in Sara McArdle’s session yesterday</a:t>
             </a:r>
             <a:endParaRPr lang="en-US" sz="2000" dirty="0"/>
           </a:p>
@@ -21604,7 +21604,7 @@
                 <a:ea typeface="Calibri" pitchFamily="34" charset="-122"/>
                 <a:cs typeface="Calibri" pitchFamily="34" charset="-120"/>
               </a:rPr>
-              <a:t>Already fixed: QPSC, the Confusion Matrix and the fibre tools are shown regardless — and Channel Names Viewer and Classify Object Subset were covered in Sara McArdle’s session earlier in the conference.
+              <a:t>Already fixed: QPSC, the Confusion Matrix and the fibre tools are shown regardless — and Channel Names Viewer and Classify Object Subset were covered in Sara McArdle’s session yesterday.
 </a:t>
             </a:r>
             <a:pPr indent="0" marL="0">

</xml_diff>

<commit_message>
Rebuild the fluorescence stitching figure from the tool's own output
The panels were my own Python compositing with a hard cut, which is the
wrong provenance for a slide about the extension and produced an
artefact of its own: a hard cut joins each tile's dim vignetted edge to
the other's, leaving a dark vertical line the tool would never show.

Both panels are now Tiles to Pyramid output, from RealTileFigureTest in
that repo, using its own registration engine.

The honest result is a better teaching point than the one I was aiming
for. Because the stitcher feathers the overlap, a 5 px stage error does
not appear as a seam at all - it appears as blur. Smeared mitochondrial
puncta and soft filaments on the stage-coordinate panel, crisp on the
measured one. The caption now says that.

Crop chosen by measuring where the two stitches actually differ most
across the overlap strip, rather than by eye.

Claude-Session: https://claude.ai/code/session_01KwiACUr5MacuDvqp74c96o
</commit_message>
<xml_diff>
--- a/I2K_2026_QuPath_Extensions.pptx
+++ b/I2K_2026_QuPath_Extensions.pptx
@@ -5815,8 +5815,159 @@
         </p:nvSpPr>
         <p:spPr>
           <a:xfrm>
+            <a:off x="10140696" y="1316736"/>
+            <a:ext cx="1481328" cy="201168"/>
+          </a:xfrm>
+          <a:prstGeom prst="rect">
+            <a:avLst/>
+          </a:prstGeom>
+          <a:noFill/>
+          <a:ln/>
+        </p:spPr>
+        <p:txBody>
+          <a:bodyPr wrap="square" rtlCol="0" anchor="ctr"/>
+          <a:lstStyle/>
+          <a:p>
+            <a:pPr algn="ctr" indent="0" marL="0">
+              <a:buNone/>
+            </a:pPr>
+            <a:r>
+              <a:rPr lang="en-US" sz="1000" b="1" dirty="0">
+                <a:solidFill>
+                  <a:srgbClr val="1F4C86"/>
+                </a:solidFill>
+                <a:latin typeface="Calibri" pitchFamily="34" charset="0"/>
+                <a:ea typeface="Calibri" pitchFamily="34" charset="-122"/>
+                <a:cs typeface="Calibri" pitchFamily="34" charset="-120"/>
+              </a:rPr>
+              <a:t>QuIET</a:t>
+            </a:r>
+            <a:endParaRPr lang="en-US" sz="1000" dirty="0"/>
+          </a:p>
+        </p:txBody>
+      </p:sp>
+      <p:sp>
+        <p:nvSpPr>
+          <p:cNvPr id="6" name="Shape 4"/>
+          <p:cNvSpPr/>
+          <p:nvPr/>
+        </p:nvSpPr>
+        <p:spPr>
+          <a:xfrm>
+            <a:off x="10264140" y="1536192"/>
+            <a:ext cx="1234440" cy="1234440"/>
+          </a:xfrm>
+          <a:prstGeom prst="rect">
+            <a:avLst/>
+          </a:prstGeom>
+          <a:solidFill>
+            <a:srgbClr val="FFFFFF"/>
+          </a:solidFill>
+          <a:ln w="9525">
+            <a:solidFill>
+              <a:srgbClr val="3674C1"/>
+            </a:solidFill>
+            <a:prstDash val="dash"/>
+          </a:ln>
+        </p:spPr>
+      </p:sp>
+      <p:sp>
+        <p:nvSpPr>
+          <p:cNvPr id="7" name="Text 5"/>
+          <p:cNvSpPr/>
+          <p:nvPr/>
+        </p:nvSpPr>
+        <p:spPr>
+          <a:xfrm>
+            <a:off x="10264140" y="1536192"/>
+            <a:ext cx="1234440" cy="1234440"/>
+          </a:xfrm>
+          <a:prstGeom prst="rect">
+            <a:avLst/>
+          </a:prstGeom>
+          <a:noFill/>
+          <a:ln/>
+        </p:spPr>
+        <p:txBody>
+          <a:bodyPr wrap="square" rtlCol="0" anchor="ctr"/>
+          <a:lstStyle/>
+          <a:p>
+            <a:pPr algn="ctr" indent="0" marL="0">
+              <a:buNone/>
+            </a:pPr>
+            <a:r>
+              <a:rPr lang="en-US" sz="1100" dirty="0">
+                <a:solidFill>
+                  <a:srgbClr val="3674C1"/>
+                </a:solidFill>
+                <a:latin typeface="Calibri" pitchFamily="34" charset="0"/>
+                <a:ea typeface="Calibri" pitchFamily="34" charset="-122"/>
+                <a:cs typeface="Calibri" pitchFamily="34" charset="-120"/>
+              </a:rPr>
+              <a:t>QR</a:t>
+            </a:r>
+            <a:endParaRPr lang="en-US" sz="1100" dirty="0"/>
+          </a:p>
+        </p:txBody>
+      </p:sp>
+      <p:sp>
+        <p:nvSpPr>
+          <p:cNvPr id="8" name="Text 6">
+            <a:hlinkClick r:id="rId1" tooltip=""/>
+          </p:cNvPr>
+          <p:cNvSpPr/>
+          <p:nvPr/>
+        </p:nvSpPr>
+        <p:spPr>
+          <a:xfrm>
+            <a:off x="10140696" y="2807208"/>
+            <a:ext cx="1481328" cy="310896"/>
+          </a:xfrm>
+          <a:prstGeom prst="rect">
+            <a:avLst/>
+          </a:prstGeom>
+          <a:noFill/>
+          <a:ln/>
+        </p:spPr>
+        <p:txBody>
+          <a:bodyPr wrap="square" rtlCol="0" anchor="ctr"/>
+          <a:lstStyle/>
+          <a:p>
+            <a:pPr algn="ctr" indent="0" marL="0">
+              <a:buNone/>
+            </a:pPr>
+            <a:r>
+              <a:rPr lang="en-US" sz="750" u="sng" dirty="0">
+                <a:solidFill>
+                  <a:srgbClr val="5A6675"/>
+                </a:solidFill>
+                <a:latin typeface="Calibri" pitchFamily="34" charset="0"/>
+                <a:ea typeface="Calibri" pitchFamily="34" charset="-122"/>
+                <a:cs typeface="Calibri" pitchFamily="34" charset="-120"/>
+                <a:hlinkClick r:id="rId1" invalidUrl="" action="" tgtFrame="" tooltip="" history="1" highlightClick="0" endSnd="0">
+                  <a:extLst>
+                    <a:ext uri="{A12FA001-AC4F-418D-AE19-62706E023703}">
+                      <ahyp:hlinkClr xmlns:ahyp="http://schemas.microsoft.com/office/drawing/2018/hyperlinkcolor" val="tx"/>
+                    </a:ext>
+                  </a:extLst>
+                </a:hlinkClick>
+              </a:rPr>
+              <a:t>github.com/uw-loci/qupath-extension-image-export-toolkit</a:t>
+            </a:r>
+            <a:endParaRPr lang="en-US" sz="750" dirty="0"/>
+          </a:p>
+        </p:txBody>
+      </p:sp>
+      <p:sp>
+        <p:nvSpPr>
+          <p:cNvPr id="9" name="Text 7"/>
+          <p:cNvSpPr/>
+          <p:nvPr/>
+        </p:nvSpPr>
+        <p:spPr>
+          <a:xfrm>
             <a:off x="640080" y="1755648"/>
-            <a:ext cx="10963656" cy="4279392"/>
+            <a:ext cx="9226296" cy="4279392"/>
           </a:xfrm>
           <a:prstGeom prst="rect">
             <a:avLst/>
@@ -5927,7 +6078,7 @@
       </p:sp>
       <p:sp>
         <p:nvSpPr>
-          <p:cNvPr id="6" name="Text 4"/>
+          <p:cNvPr id="10" name="Text 8"/>
           <p:cNvSpPr/>
           <p:nvPr/>
         </p:nvSpPr>
@@ -6681,8 +6832,159 @@
         </p:nvSpPr>
         <p:spPr>
           <a:xfrm>
+            <a:off x="10140696" y="1280160"/>
+            <a:ext cx="1481328" cy="201168"/>
+          </a:xfrm>
+          <a:prstGeom prst="rect">
+            <a:avLst/>
+          </a:prstGeom>
+          <a:noFill/>
+          <a:ln/>
+        </p:spPr>
+        <p:txBody>
+          <a:bodyPr wrap="square" rtlCol="0" anchor="ctr"/>
+          <a:lstStyle/>
+          <a:p>
+            <a:pPr algn="ctr" indent="0" marL="0">
+              <a:buNone/>
+            </a:pPr>
+            <a:r>
+              <a:rPr lang="en-US" sz="1000" b="1" dirty="0">
+                <a:solidFill>
+                  <a:srgbClr val="1F4C86"/>
+                </a:solidFill>
+                <a:latin typeface="Calibri" pitchFamily="34" charset="0"/>
+                <a:ea typeface="Calibri" pitchFamily="34" charset="-122"/>
+                <a:cs typeface="Calibri" pitchFamily="34" charset="-120"/>
+              </a:rPr>
+              <a:t>OCR for Labels</a:t>
+            </a:r>
+            <a:endParaRPr lang="en-US" sz="1000" dirty="0"/>
+          </a:p>
+        </p:txBody>
+      </p:sp>
+      <p:sp>
+        <p:nvSpPr>
+          <p:cNvPr id="5" name="Shape 3"/>
+          <p:cNvSpPr/>
+          <p:nvPr/>
+        </p:nvSpPr>
+        <p:spPr>
+          <a:xfrm>
+            <a:off x="10264140" y="1499616"/>
+            <a:ext cx="1234440" cy="1234440"/>
+          </a:xfrm>
+          <a:prstGeom prst="rect">
+            <a:avLst/>
+          </a:prstGeom>
+          <a:solidFill>
+            <a:srgbClr val="FFFFFF"/>
+          </a:solidFill>
+          <a:ln w="9525">
+            <a:solidFill>
+              <a:srgbClr val="3674C1"/>
+            </a:solidFill>
+            <a:prstDash val="dash"/>
+          </a:ln>
+        </p:spPr>
+      </p:sp>
+      <p:sp>
+        <p:nvSpPr>
+          <p:cNvPr id="6" name="Text 4"/>
+          <p:cNvSpPr/>
+          <p:nvPr/>
+        </p:nvSpPr>
+        <p:spPr>
+          <a:xfrm>
+            <a:off x="10264140" y="1499616"/>
+            <a:ext cx="1234440" cy="1234440"/>
+          </a:xfrm>
+          <a:prstGeom prst="rect">
+            <a:avLst/>
+          </a:prstGeom>
+          <a:noFill/>
+          <a:ln/>
+        </p:spPr>
+        <p:txBody>
+          <a:bodyPr wrap="square" rtlCol="0" anchor="ctr"/>
+          <a:lstStyle/>
+          <a:p>
+            <a:pPr algn="ctr" indent="0" marL="0">
+              <a:buNone/>
+            </a:pPr>
+            <a:r>
+              <a:rPr lang="en-US" sz="1100" dirty="0">
+                <a:solidFill>
+                  <a:srgbClr val="3674C1"/>
+                </a:solidFill>
+                <a:latin typeface="Calibri" pitchFamily="34" charset="0"/>
+                <a:ea typeface="Calibri" pitchFamily="34" charset="-122"/>
+                <a:cs typeface="Calibri" pitchFamily="34" charset="-120"/>
+              </a:rPr>
+              <a:t>QR</a:t>
+            </a:r>
+            <a:endParaRPr lang="en-US" sz="1100" dirty="0"/>
+          </a:p>
+        </p:txBody>
+      </p:sp>
+      <p:sp>
+        <p:nvSpPr>
+          <p:cNvPr id="7" name="Text 5">
+            <a:hlinkClick r:id="rId1" tooltip=""/>
+          </p:cNvPr>
+          <p:cNvSpPr/>
+          <p:nvPr/>
+        </p:nvSpPr>
+        <p:spPr>
+          <a:xfrm>
+            <a:off x="10140696" y="2770632"/>
+            <a:ext cx="1481328" cy="310896"/>
+          </a:xfrm>
+          <a:prstGeom prst="rect">
+            <a:avLst/>
+          </a:prstGeom>
+          <a:noFill/>
+          <a:ln/>
+        </p:spPr>
+        <p:txBody>
+          <a:bodyPr wrap="square" rtlCol="0" anchor="ctr"/>
+          <a:lstStyle/>
+          <a:p>
+            <a:pPr algn="ctr" indent="0" marL="0">
+              <a:buNone/>
+            </a:pPr>
+            <a:r>
+              <a:rPr lang="en-US" sz="750" u="sng" dirty="0">
+                <a:solidFill>
+                  <a:srgbClr val="5A6675"/>
+                </a:solidFill>
+                <a:latin typeface="Calibri" pitchFamily="34" charset="0"/>
+                <a:ea typeface="Calibri" pitchFamily="34" charset="-122"/>
+                <a:cs typeface="Calibri" pitchFamily="34" charset="-120"/>
+                <a:hlinkClick r:id="rId1" invalidUrl="" action="" tgtFrame="" tooltip="" history="1" highlightClick="0" endSnd="0">
+                  <a:extLst>
+                    <a:ext uri="{A12FA001-AC4F-418D-AE19-62706E023703}">
+                      <ahyp:hlinkClr xmlns:ahyp="http://schemas.microsoft.com/office/drawing/2018/hyperlinkcolor" val="tx"/>
+                    </a:ext>
+                  </a:extLst>
+                </a:hlinkClick>
+              </a:rPr>
+              <a:t>github.com/uw-loci/qupath-extension-ocr4labels</a:t>
+            </a:r>
+            <a:endParaRPr lang="en-US" sz="750" dirty="0"/>
+          </a:p>
+        </p:txBody>
+      </p:sp>
+      <p:sp>
+        <p:nvSpPr>
+          <p:cNvPr id="8" name="Text 6"/>
+          <p:cNvSpPr/>
+          <p:nvPr/>
+        </p:nvSpPr>
+        <p:spPr>
+          <a:xfrm>
             <a:off x="640080" y="1481328"/>
-            <a:ext cx="10963656" cy="4553712"/>
+            <a:ext cx="9226296" cy="4553712"/>
           </a:xfrm>
           <a:prstGeom prst="rect">
             <a:avLst/>
@@ -6793,7 +7095,7 @@
       </p:sp>
       <p:sp>
         <p:nvSpPr>
-          <p:cNvPr id="5" name="Shape 3"/>
+          <p:cNvPr id="9" name="Shape 7"/>
           <p:cNvSpPr/>
           <p:nvPr/>
         </p:nvSpPr>
@@ -6818,7 +7120,7 @@
       </p:sp>
       <p:sp>
         <p:nvSpPr>
-          <p:cNvPr id="6" name="Text 4"/>
+          <p:cNvPr id="10" name="Text 8"/>
           <p:cNvSpPr/>
           <p:nvPr/>
         </p:nvSpPr>
@@ -6857,7 +7159,7 @@
       </p:sp>
       <p:sp>
         <p:nvSpPr>
-          <p:cNvPr id="7" name="Text 5"/>
+          <p:cNvPr id="11" name="Text 9"/>
           <p:cNvSpPr/>
           <p:nvPr/>
         </p:nvSpPr>
@@ -7032,8 +7334,159 @@
         </p:nvSpPr>
         <p:spPr>
           <a:xfrm>
+            <a:off x="10140696" y="1316736"/>
+            <a:ext cx="1481328" cy="201168"/>
+          </a:xfrm>
+          <a:prstGeom prst="rect">
+            <a:avLst/>
+          </a:prstGeom>
+          <a:noFill/>
+          <a:ln/>
+        </p:spPr>
+        <p:txBody>
+          <a:bodyPr wrap="square" rtlCol="0" anchor="ctr"/>
+          <a:lstStyle/>
+          <a:p>
+            <a:pPr algn="ctr" indent="0" marL="0">
+              <a:buNone/>
+            </a:pPr>
+            <a:r>
+              <a:rPr lang="en-US" sz="1000" b="1" dirty="0">
+                <a:solidFill>
+                  <a:srgbClr val="1F4C86"/>
+                </a:solidFill>
+                <a:latin typeface="Calibri" pitchFamily="34" charset="0"/>
+                <a:ea typeface="Calibri" pitchFamily="34" charset="-122"/>
+                <a:cs typeface="Calibri" pitchFamily="34" charset="-120"/>
+              </a:rPr>
+              <a:t>Metadata Browser</a:t>
+            </a:r>
+            <a:endParaRPr lang="en-US" sz="1000" dirty="0"/>
+          </a:p>
+        </p:txBody>
+      </p:sp>
+      <p:sp>
+        <p:nvSpPr>
+          <p:cNvPr id="6" name="Shape 4"/>
+          <p:cNvSpPr/>
+          <p:nvPr/>
+        </p:nvSpPr>
+        <p:spPr>
+          <a:xfrm>
+            <a:off x="10264140" y="1536192"/>
+            <a:ext cx="1234440" cy="1234440"/>
+          </a:xfrm>
+          <a:prstGeom prst="rect">
+            <a:avLst/>
+          </a:prstGeom>
+          <a:solidFill>
+            <a:srgbClr val="FFFFFF"/>
+          </a:solidFill>
+          <a:ln w="9525">
+            <a:solidFill>
+              <a:srgbClr val="3674C1"/>
+            </a:solidFill>
+            <a:prstDash val="dash"/>
+          </a:ln>
+        </p:spPr>
+      </p:sp>
+      <p:sp>
+        <p:nvSpPr>
+          <p:cNvPr id="7" name="Text 5"/>
+          <p:cNvSpPr/>
+          <p:nvPr/>
+        </p:nvSpPr>
+        <p:spPr>
+          <a:xfrm>
+            <a:off x="10264140" y="1536192"/>
+            <a:ext cx="1234440" cy="1234440"/>
+          </a:xfrm>
+          <a:prstGeom prst="rect">
+            <a:avLst/>
+          </a:prstGeom>
+          <a:noFill/>
+          <a:ln/>
+        </p:spPr>
+        <p:txBody>
+          <a:bodyPr wrap="square" rtlCol="0" anchor="ctr"/>
+          <a:lstStyle/>
+          <a:p>
+            <a:pPr algn="ctr" indent="0" marL="0">
+              <a:buNone/>
+            </a:pPr>
+            <a:r>
+              <a:rPr lang="en-US" sz="1100" dirty="0">
+                <a:solidFill>
+                  <a:srgbClr val="3674C1"/>
+                </a:solidFill>
+                <a:latin typeface="Calibri" pitchFamily="34" charset="0"/>
+                <a:ea typeface="Calibri" pitchFamily="34" charset="-122"/>
+                <a:cs typeface="Calibri" pitchFamily="34" charset="-120"/>
+              </a:rPr>
+              <a:t>QR</a:t>
+            </a:r>
+            <a:endParaRPr lang="en-US" sz="1100" dirty="0"/>
+          </a:p>
+        </p:txBody>
+      </p:sp>
+      <p:sp>
+        <p:nvSpPr>
+          <p:cNvPr id="8" name="Text 6">
+            <a:hlinkClick r:id="rId1" tooltip=""/>
+          </p:cNvPr>
+          <p:cNvSpPr/>
+          <p:nvPr/>
+        </p:nvSpPr>
+        <p:spPr>
+          <a:xfrm>
+            <a:off x="10140696" y="2807208"/>
+            <a:ext cx="1481328" cy="310896"/>
+          </a:xfrm>
+          <a:prstGeom prst="rect">
+            <a:avLst/>
+          </a:prstGeom>
+          <a:noFill/>
+          <a:ln/>
+        </p:spPr>
+        <p:txBody>
+          <a:bodyPr wrap="square" rtlCol="0" anchor="ctr"/>
+          <a:lstStyle/>
+          <a:p>
+            <a:pPr algn="ctr" indent="0" marL="0">
+              <a:buNone/>
+            </a:pPr>
+            <a:r>
+              <a:rPr lang="en-US" sz="750" u="sng" dirty="0">
+                <a:solidFill>
+                  <a:srgbClr val="5A6675"/>
+                </a:solidFill>
+                <a:latin typeface="Calibri" pitchFamily="34" charset="0"/>
+                <a:ea typeface="Calibri" pitchFamily="34" charset="-122"/>
+                <a:cs typeface="Calibri" pitchFamily="34" charset="-120"/>
+                <a:hlinkClick r:id="rId1" invalidUrl="" action="" tgtFrame="" tooltip="" history="1" highlightClick="0" endSnd="0">
+                  <a:extLst>
+                    <a:ext uri="{A12FA001-AC4F-418D-AE19-62706E023703}">
+                      <ahyp:hlinkClr xmlns:ahyp="http://schemas.microsoft.com/office/drawing/2018/hyperlinkcolor" val="tx"/>
+                    </a:ext>
+                  </a:extLst>
+                </a:hlinkClick>
+              </a:rPr>
+              <a:t>github.com/uw-loci/qupath-extension-project-metadata-browser</a:t>
+            </a:r>
+            <a:endParaRPr lang="en-US" sz="750" dirty="0"/>
+          </a:p>
+        </p:txBody>
+      </p:sp>
+      <p:sp>
+        <p:nvSpPr>
+          <p:cNvPr id="9" name="Text 7"/>
+          <p:cNvSpPr/>
+          <p:nvPr/>
+        </p:nvSpPr>
+        <p:spPr>
+          <a:xfrm>
             <a:off x="640080" y="1755648"/>
-            <a:ext cx="10963656" cy="4279392"/>
+            <a:ext cx="9226296" cy="4279392"/>
           </a:xfrm>
           <a:prstGeom prst="rect">
             <a:avLst/>
@@ -7144,7 +7597,7 @@
       </p:sp>
       <p:sp>
         <p:nvSpPr>
-          <p:cNvPr id="6" name="Shape 4"/>
+          <p:cNvPr id="10" name="Shape 8"/>
           <p:cNvSpPr/>
           <p:nvPr/>
         </p:nvSpPr>
@@ -7169,7 +7622,7 @@
       </p:sp>
       <p:sp>
         <p:nvSpPr>
-          <p:cNvPr id="7" name="Text 5"/>
+          <p:cNvPr id="11" name="Text 9"/>
           <p:cNvSpPr/>
           <p:nvPr/>
         </p:nvSpPr>
@@ -7208,7 +7661,7 @@
       </p:sp>
       <p:sp>
         <p:nvSpPr>
-          <p:cNvPr id="8" name="Text 6"/>
+          <p:cNvPr id="12" name="Text 10"/>
           <p:cNvSpPr/>
           <p:nvPr/>
         </p:nvSpPr>
@@ -7344,8 +7797,159 @@
         </p:nvSpPr>
         <p:spPr>
           <a:xfrm>
+            <a:off x="10140696" y="1280160"/>
+            <a:ext cx="1481328" cy="201168"/>
+          </a:xfrm>
+          <a:prstGeom prst="rect">
+            <a:avLst/>
+          </a:prstGeom>
+          <a:noFill/>
+          <a:ln/>
+        </p:spPr>
+        <p:txBody>
+          <a:bodyPr wrap="square" rtlCol="0" anchor="ctr"/>
+          <a:lstStyle/>
+          <a:p>
+            <a:pPr algn="ctr" indent="0" marL="0">
+              <a:buNone/>
+            </a:pPr>
+            <a:r>
+              <a:rPr lang="en-US" sz="1000" b="1" dirty="0">
+                <a:solidFill>
+                  <a:srgbClr val="1F4C86"/>
+                </a:solidFill>
+                <a:latin typeface="Calibri" pitchFamily="34" charset="0"/>
+                <a:ea typeface="Calibri" pitchFamily="34" charset="-122"/>
+                <a:cs typeface="Calibri" pitchFamily="34" charset="-120"/>
+              </a:rPr>
+              <a:t>Class Distribution</a:t>
+            </a:r>
+            <a:endParaRPr lang="en-US" sz="1000" dirty="0"/>
+          </a:p>
+        </p:txBody>
+      </p:sp>
+      <p:sp>
+        <p:nvSpPr>
+          <p:cNvPr id="5" name="Shape 3"/>
+          <p:cNvSpPr/>
+          <p:nvPr/>
+        </p:nvSpPr>
+        <p:spPr>
+          <a:xfrm>
+            <a:off x="10264140" y="1499616"/>
+            <a:ext cx="1234440" cy="1234440"/>
+          </a:xfrm>
+          <a:prstGeom prst="rect">
+            <a:avLst/>
+          </a:prstGeom>
+          <a:solidFill>
+            <a:srgbClr val="FFFFFF"/>
+          </a:solidFill>
+          <a:ln w="9525">
+            <a:solidFill>
+              <a:srgbClr val="3674C1"/>
+            </a:solidFill>
+            <a:prstDash val="dash"/>
+          </a:ln>
+        </p:spPr>
+      </p:sp>
+      <p:sp>
+        <p:nvSpPr>
+          <p:cNvPr id="6" name="Text 4"/>
+          <p:cNvSpPr/>
+          <p:nvPr/>
+        </p:nvSpPr>
+        <p:spPr>
+          <a:xfrm>
+            <a:off x="10264140" y="1499616"/>
+            <a:ext cx="1234440" cy="1234440"/>
+          </a:xfrm>
+          <a:prstGeom prst="rect">
+            <a:avLst/>
+          </a:prstGeom>
+          <a:noFill/>
+          <a:ln/>
+        </p:spPr>
+        <p:txBody>
+          <a:bodyPr wrap="square" rtlCol="0" anchor="ctr"/>
+          <a:lstStyle/>
+          <a:p>
+            <a:pPr algn="ctr" indent="0" marL="0">
+              <a:buNone/>
+            </a:pPr>
+            <a:r>
+              <a:rPr lang="en-US" sz="1100" dirty="0">
+                <a:solidFill>
+                  <a:srgbClr val="3674C1"/>
+                </a:solidFill>
+                <a:latin typeface="Calibri" pitchFamily="34" charset="0"/>
+                <a:ea typeface="Calibri" pitchFamily="34" charset="-122"/>
+                <a:cs typeface="Calibri" pitchFamily="34" charset="-120"/>
+              </a:rPr>
+              <a:t>QR</a:t>
+            </a:r>
+            <a:endParaRPr lang="en-US" sz="1100" dirty="0"/>
+          </a:p>
+        </p:txBody>
+      </p:sp>
+      <p:sp>
+        <p:nvSpPr>
+          <p:cNvPr id="7" name="Text 5">
+            <a:hlinkClick r:id="rId1" tooltip=""/>
+          </p:cNvPr>
+          <p:cNvSpPr/>
+          <p:nvPr/>
+        </p:nvSpPr>
+        <p:spPr>
+          <a:xfrm>
+            <a:off x="10140696" y="2770632"/>
+            <a:ext cx="1481328" cy="310896"/>
+          </a:xfrm>
+          <a:prstGeom prst="rect">
+            <a:avLst/>
+          </a:prstGeom>
+          <a:noFill/>
+          <a:ln/>
+        </p:spPr>
+        <p:txBody>
+          <a:bodyPr wrap="square" rtlCol="0" anchor="ctr"/>
+          <a:lstStyle/>
+          <a:p>
+            <a:pPr algn="ctr" indent="0" marL="0">
+              <a:buNone/>
+            </a:pPr>
+            <a:r>
+              <a:rPr lang="en-US" sz="750" u="sng" dirty="0">
+                <a:solidFill>
+                  <a:srgbClr val="5A6675"/>
+                </a:solidFill>
+                <a:latin typeface="Calibri" pitchFamily="34" charset="0"/>
+                <a:ea typeface="Calibri" pitchFamily="34" charset="-122"/>
+                <a:cs typeface="Calibri" pitchFamily="34" charset="-120"/>
+                <a:hlinkClick r:id="rId1" invalidUrl="" action="" tgtFrame="" tooltip="" history="1" highlightClick="0" endSnd="0">
+                  <a:extLst>
+                    <a:ext uri="{A12FA001-AC4F-418D-AE19-62706E023703}">
+                      <ahyp:hlinkClr xmlns:ahyp="http://schemas.microsoft.com/office/drawing/2018/hyperlinkcolor" val="tx"/>
+                    </a:ext>
+                  </a:extLst>
+                </a:hlinkClick>
+              </a:rPr>
+              <a:t>github.com/uw-loci/qupath-extension-class-distribution</a:t>
+            </a:r>
+            <a:endParaRPr lang="en-US" sz="750" dirty="0"/>
+          </a:p>
+        </p:txBody>
+      </p:sp>
+      <p:sp>
+        <p:nvSpPr>
+          <p:cNvPr id="8" name="Text 6"/>
+          <p:cNvSpPr/>
+          <p:nvPr/>
+        </p:nvSpPr>
+        <p:spPr>
+          <a:xfrm>
             <a:off x="640080" y="1481328"/>
-            <a:ext cx="10963656" cy="4553712"/>
+            <a:ext cx="9226296" cy="4553712"/>
           </a:xfrm>
           <a:prstGeom prst="rect">
             <a:avLst/>
@@ -7456,7 +8060,7 @@
       </p:sp>
       <p:sp>
         <p:nvSpPr>
-          <p:cNvPr id="5" name="Shape 3"/>
+          <p:cNvPr id="9" name="Shape 7"/>
           <p:cNvSpPr/>
           <p:nvPr/>
         </p:nvSpPr>
@@ -7481,7 +8085,7 @@
       </p:sp>
       <p:sp>
         <p:nvSpPr>
-          <p:cNvPr id="6" name="Text 4"/>
+          <p:cNvPr id="10" name="Text 8"/>
           <p:cNvSpPr/>
           <p:nvPr/>
         </p:nvSpPr>
@@ -7520,7 +8124,7 @@
       </p:sp>
       <p:sp>
         <p:nvSpPr>
-          <p:cNvPr id="7" name="Text 5"/>
+          <p:cNvPr id="11" name="Text 9"/>
           <p:cNvSpPr/>
           <p:nvPr/>
         </p:nvSpPr>
@@ -8331,8 +8935,8 @@
         </p:nvSpPr>
         <p:spPr>
           <a:xfrm>
-            <a:off x="566928" y="1572768"/>
-            <a:ext cx="11055096" cy="2240280"/>
+            <a:off x="566928" y="1517904"/>
+            <a:ext cx="11055096" cy="1755648"/>
           </a:xfrm>
           <a:prstGeom prst="rect">
             <a:avLst/>
@@ -8351,8 +8955,8 @@
         </p:nvSpPr>
         <p:spPr>
           <a:xfrm>
-            <a:off x="566928" y="1572768"/>
-            <a:ext cx="146304" cy="2240280"/>
+            <a:off x="566928" y="1517904"/>
+            <a:ext cx="146304" cy="1755648"/>
           </a:xfrm>
           <a:prstGeom prst="rect">
             <a:avLst/>
@@ -8371,8 +8975,8 @@
         </p:nvSpPr>
         <p:spPr>
           <a:xfrm>
-            <a:off x="978408" y="1737360"/>
-            <a:ext cx="10232136" cy="365760"/>
+            <a:off x="978408" y="1645920"/>
+            <a:ext cx="10232136" cy="310896"/>
           </a:xfrm>
           <a:prstGeom prst="rect">
             <a:avLst/>
@@ -8388,7 +8992,7 @@
               <a:buNone/>
             </a:pPr>
             <a:r>
-              <a:rPr lang="en-US" sz="1600" b="1" spc="150" kern="0" dirty="0">
+              <a:rPr lang="en-US" sz="1500" b="1" spc="150" kern="0" dirty="0">
                 <a:solidFill>
                   <a:srgbClr val="3674C1"/>
                 </a:solidFill>
@@ -8396,9 +9000,9 @@
                 <a:ea typeface="Calibri" pitchFamily="34" charset="-122"/>
                 <a:cs typeface="Calibri" pitchFamily="34" charset="-120"/>
               </a:rPr>
-              <a:t>Sample data</a:t>
-            </a:r>
-            <a:endParaRPr lang="en-US" sz="1600" dirty="0"/>
+              <a:t>LOCI</a:t>
+            </a:r>
+            <a:endParaRPr lang="en-US" sz="1500" dirty="0"/>
           </a:p>
         </p:txBody>
       </p:sp>
@@ -8410,8 +9014,8 @@
         </p:nvSpPr>
         <p:spPr>
           <a:xfrm>
-            <a:off x="978408" y="2103120"/>
-            <a:ext cx="10232136" cy="566928"/>
+            <a:off x="978408" y="1938528"/>
+            <a:ext cx="10232136" cy="530352"/>
           </a:xfrm>
           <a:prstGeom prst="rect">
             <a:avLst/>
@@ -8427,7 +9031,7 @@
               <a:buNone/>
             </a:pPr>
             <a:r>
-              <a:rPr lang="en-US" sz="3200" b="1" dirty="0">
+              <a:rPr lang="en-US" sz="3000" b="1" dirty="0">
                 <a:solidFill>
                   <a:srgbClr val="1F4C86"/>
                 </a:solidFill>
@@ -8435,9 +9039,9 @@
                 <a:ea typeface="Trebuchet MS" pitchFamily="34" charset="-122"/>
                 <a:cs typeface="Trebuchet MS" pitchFamily="34" charset="-120"/>
               </a:rPr>
-              <a:t>Sara McArdle  ·  Zbigniew Mikulski</a:t>
-            </a:r>
-            <a:endParaRPr lang="en-US" sz="3200" dirty="0"/>
+              <a:t>The lab, and Kevin Eliceiri</a:t>
+            </a:r>
+            <a:endParaRPr lang="en-US" sz="3000" dirty="0"/>
           </a:p>
         </p:txBody>
       </p:sp>
@@ -8449,47 +9053,8 @@
         </p:nvSpPr>
         <p:spPr>
           <a:xfrm>
-            <a:off x="978408" y="2670048"/>
-            <a:ext cx="10232136" cy="384048"/>
-          </a:xfrm>
-          <a:prstGeom prst="rect">
-            <a:avLst/>
-          </a:prstGeom>
-          <a:noFill/>
-          <a:ln/>
-        </p:spPr>
-        <p:txBody>
-          <a:bodyPr wrap="square" rtlCol="0" anchor="ctr"/>
-          <a:lstStyle/>
-          <a:p>
-            <a:pPr indent="0" marL="0">
-              <a:buNone/>
-            </a:pPr>
-            <a:r>
-              <a:rPr lang="en-US" sz="2100" dirty="0">
-                <a:solidFill>
-                  <a:srgbClr val="1F2933"/>
-                </a:solidFill>
-                <a:latin typeface="Calibri" pitchFamily="34" charset="0"/>
-                <a:ea typeface="Calibri" pitchFamily="34" charset="-122"/>
-                <a:cs typeface="Calibri" pitchFamily="34" charset="-120"/>
-              </a:rPr>
-              <a:t>La Jolla Institute for Immunology</a:t>
-            </a:r>
-            <a:endParaRPr lang="en-US" sz="2100" dirty="0"/>
-          </a:p>
-        </p:txBody>
-      </p:sp>
-      <p:sp>
-        <p:nvSpPr>
-          <p:cNvPr id="9" name="Text 7"/>
-          <p:cNvSpPr/>
-          <p:nvPr/>
-        </p:nvSpPr>
-        <p:spPr>
-          <a:xfrm>
-            <a:off x="978408" y="3054096"/>
-            <a:ext cx="10232136" cy="731520"/>
+            <a:off x="978408" y="2487168"/>
+            <a:ext cx="10232136" cy="694944"/>
           </a:xfrm>
           <a:prstGeom prst="rect">
             <a:avLst/>
@@ -8516,42 +9081,22 @@
                 <a:ea typeface="Calibri" pitchFamily="34" charset="-122"/>
                 <a:cs typeface="Calibri" pitchFamily="34" charset="-120"/>
               </a:rPr>
-              <a:t>They provided the slide-label images behind the OCR and metadata exercises.</a:t>
+              <a:t>For a genuinely collaborative lab, and for backing work on QuPath that sits well outside my job description.</a:t>
             </a:r>
             <a:endParaRPr lang="en-US" sz="1700" dirty="0"/>
           </a:p>
-          <a:p>
-            <a:pPr indent="0" marL="0">
-              <a:lnSpc>
-                <a:spcPct val="110000"/>
-              </a:lnSpc>
-              <a:buNone/>
-            </a:pPr>
-            <a:r>
-              <a:rPr lang="en-US" sz="1700" i="1" dirty="0">
-                <a:solidFill>
-                  <a:srgbClr val="5A6675"/>
-                </a:solidFill>
-                <a:latin typeface="Calibri" pitchFamily="34" charset="0"/>
-                <a:ea typeface="Calibri" pitchFamily="34" charset="-122"/>
-                <a:cs typeface="Calibri" pitchFamily="34" charset="-120"/>
-              </a:rPr>
-              <a:t>Other data today: public images, a CC0 synthetic set, and tiles acquired at LOCI.</a:t>
-            </a:r>
-            <a:endParaRPr lang="en-US" sz="1700" dirty="0"/>
-          </a:p>
-        </p:txBody>
-      </p:sp>
-      <p:sp>
-        <p:nvSpPr>
-          <p:cNvPr id="10" name="Text 8"/>
-          <p:cNvSpPr/>
-          <p:nvPr/>
-        </p:nvSpPr>
-        <p:spPr>
-          <a:xfrm>
-            <a:off x="566928" y="3977640"/>
-            <a:ext cx="11055096" cy="2103120"/>
+        </p:txBody>
+      </p:sp>
+      <p:sp>
+        <p:nvSpPr>
+          <p:cNvPr id="9" name="Text 7"/>
+          <p:cNvSpPr/>
+          <p:nvPr/>
+        </p:nvSpPr>
+        <p:spPr>
+          <a:xfrm>
+            <a:off x="566928" y="3419856"/>
+            <a:ext cx="11055096" cy="2743200"/>
           </a:xfrm>
           <a:prstGeom prst="rect">
             <a:avLst/>
@@ -8565,12 +9110,30 @@
           <a:p>
             <a:pPr indent="0" marL="0">
               <a:spcAft>
-                <a:spcPts val="1000"/>
+                <a:spcPts val="900"/>
               </a:spcAft>
               <a:buNone/>
             </a:pPr>
             <a:r>
-              <a:rPr lang="en-US" sz="1700" dirty="0">
+              <a:rPr lang="en-US" sz="1600" dirty="0">
+                <a:solidFill>
+                  <a:srgbClr val="1F2933"/>
+                </a:solidFill>
+                <a:latin typeface="Calibri" pitchFamily="34" charset="0"/>
+                <a:ea typeface="Calibri" pitchFamily="34" charset="-122"/>
+                <a:cs typeface="Calibri" pitchFamily="34" charset="-120"/>
+              </a:rPr>
+              <a:t>Sample data: Sara McArdle and Zbigniew Mikulski, La Jolla Institute for Immunology, who provided the slide-label images behind the OCR and metadata exercises. Other data today: public images, a CC0 synthetic set, and tiles acquired at LOCI.
+</a:t>
+            </a:r>
+            <a:pPr indent="0" marL="0">
+              <a:spcAft>
+                <a:spcPts val="900"/>
+              </a:spcAft>
+              <a:buNone/>
+            </a:pPr>
+            <a:r>
+              <a:rPr lang="en-US" sz="1600" dirty="0">
                 <a:solidFill>
                   <a:srgbClr val="1F2933"/>
                 </a:solidFill>
@@ -8583,12 +9146,12 @@
             </a:r>
             <a:pPr indent="0" marL="0">
               <a:spcAft>
-                <a:spcPts val="1000"/>
+                <a:spcPts val="900"/>
               </a:spcAft>
               <a:buNone/>
             </a:pPr>
             <a:r>
-              <a:rPr lang="en-US" sz="1700" dirty="0">
+              <a:rPr lang="en-US" sz="1600" dirty="0">
                 <a:solidFill>
                   <a:srgbClr val="1F2933"/>
                 </a:solidFill>
@@ -8601,12 +9164,12 @@
             </a:r>
             <a:pPr indent="0" marL="0">
               <a:spcAft>
-                <a:spcPts val="1000"/>
+                <a:spcPts val="900"/>
               </a:spcAft>
               <a:buNone/>
             </a:pPr>
             <a:r>
-              <a:rPr lang="en-US" sz="1700" dirty="0">
+              <a:rPr lang="en-US" sz="1600" dirty="0">
                 <a:solidFill>
                   <a:srgbClr val="1F2933"/>
                 </a:solidFill>
@@ -8621,7 +9184,7 @@
               <a:buNone/>
             </a:pPr>
             <a:r>
-              <a:rPr lang="en-US" sz="1700" b="1" dirty="0">
+              <a:rPr lang="en-US" sz="1600" b="1" dirty="0">
                 <a:solidFill>
                   <a:srgbClr val="1F4C86"/>
                 </a:solidFill>
@@ -8631,13 +9194,13 @@
               </a:rPr>
               <a:t>Full credits: michaelsnelson.github.io/BINA-I2K-2026-QuPath-Extensions/docs/acknowledgements.html</a:t>
             </a:r>
-            <a:endParaRPr lang="en-US" sz="1700" dirty="0"/>
-          </a:p>
-        </p:txBody>
-      </p:sp>
-      <p:sp>
-        <p:nvSpPr>
-          <p:cNvPr id="11" name="Text 9"/>
+            <a:endParaRPr lang="en-US" sz="1600" dirty="0"/>
+          </a:p>
+        </p:txBody>
+      </p:sp>
+      <p:sp>
+        <p:nvSpPr>
+          <p:cNvPr id="10" name="Text 8"/>
           <p:cNvSpPr/>
           <p:nvPr/>
         </p:nvSpPr>
@@ -9107,7 +9670,7 @@
                 <a:ea typeface="Calibri" pitchFamily="34" charset="-122"/>
                 <a:cs typeface="Calibri" pitchFamily="34" charset="-120"/>
               </a:rPr>
-              <a:t>Placed where the stage said it was</a:t>
+              <a:t>Stitched on the stage’s own coordinates</a:t>
             </a:r>
             <a:endParaRPr lang="en-US" sz="1700" dirty="0"/>
           </a:p>
@@ -9130,7 +9693,7 @@
         <p:spPr>
           <a:xfrm>
             <a:off x="768096" y="1783080"/>
-            <a:ext cx="5120640" cy="4118776"/>
+            <a:ext cx="5120640" cy="3925824"/>
           </a:xfrm>
           <a:prstGeom prst="rect">
             <a:avLst/>
@@ -9170,7 +9733,7 @@
                 <a:ea typeface="Calibri" pitchFamily="34" charset="-122"/>
                 <a:cs typeface="Calibri" pitchFamily="34" charset="-120"/>
               </a:rPr>
-              <a:t>Placed where the image content says it is</a:t>
+              <a:t>Stitched on positions measured from the image</a:t>
             </a:r>
             <a:endParaRPr lang="en-US" sz="1700" dirty="0"/>
           </a:p>
@@ -9193,7 +9756,7 @@
         <p:spPr>
           <a:xfrm>
             <a:off x="6300216" y="1783080"/>
-            <a:ext cx="5120640" cy="4118776"/>
+            <a:ext cx="5120640" cy="3925824"/>
           </a:xfrm>
           <a:prstGeom prst="rect">
             <a:avLst/>
@@ -9208,7 +9771,7 @@
         </p:nvSpPr>
         <p:spPr>
           <a:xfrm>
-            <a:off x="566928" y="6011584"/>
+            <a:off x="566928" y="5818632"/>
             <a:ext cx="11055096" cy="566928"/>
           </a:xfrm>
           <a:prstGeom prst="rect">
@@ -9233,7 +9796,7 @@
                 <a:ea typeface="Calibri" pitchFamily="34" charset="-122"/>
                 <a:cs typeface="Calibri" pitchFamily="34" charset="-120"/>
               </a:rPr>
-              <a:t>The same join through the same cells; only the tile positions differ. Positions were measured on DAPI, the channel with the clearest, best separated structure in this sample, and reused unchanged for the other two channels — so every channel stays aligned with every other. Nuclei blue, actin green, mitochondria red; the correction here is 7 px, about 4.6 µm.</a:t>
+              <a:t>Both panels are Tiles to Pyramid’s own output, at the same place in the same overlap. The stage was about 5 px out; because the tiles are feathered together, that error does not show up as a seam, it shows up as blur — smeared puncta and soft filaments on the left, crisp on the right. Positions were solved once on DAPI and reused unchanged for green and red.</a:t>
             </a:r>
             <a:endParaRPr lang="en-US" sz="1500" dirty="0"/>
           </a:p>
@@ -9711,8 +10274,159 @@
         </p:nvSpPr>
         <p:spPr>
           <a:xfrm>
+            <a:off x="10140696" y="1316736"/>
+            <a:ext cx="1481328" cy="201168"/>
+          </a:xfrm>
+          <a:prstGeom prst="rect">
+            <a:avLst/>
+          </a:prstGeom>
+          <a:noFill/>
+          <a:ln/>
+        </p:spPr>
+        <p:txBody>
+          <a:bodyPr wrap="square" rtlCol="0" anchor="ctr"/>
+          <a:lstStyle/>
+          <a:p>
+            <a:pPr algn="ctr" indent="0" marL="0">
+              <a:buNone/>
+            </a:pPr>
+            <a:r>
+              <a:rPr lang="en-US" sz="1000" b="1" dirty="0">
+                <a:solidFill>
+                  <a:srgbClr val="1F4C86"/>
+                </a:solidFill>
+                <a:latin typeface="Calibri" pitchFamily="34" charset="0"/>
+                <a:ea typeface="Calibri" pitchFamily="34" charset="-122"/>
+                <a:cs typeface="Calibri" pitchFamily="34" charset="-120"/>
+              </a:rPr>
+              <a:t>Tiles to Pyramid</a:t>
+            </a:r>
+            <a:endParaRPr lang="en-US" sz="1000" dirty="0"/>
+          </a:p>
+        </p:txBody>
+      </p:sp>
+      <p:sp>
+        <p:nvSpPr>
+          <p:cNvPr id="6" name="Shape 4"/>
+          <p:cNvSpPr/>
+          <p:nvPr/>
+        </p:nvSpPr>
+        <p:spPr>
+          <a:xfrm>
+            <a:off x="10264140" y="1536192"/>
+            <a:ext cx="1234440" cy="1234440"/>
+          </a:xfrm>
+          <a:prstGeom prst="rect">
+            <a:avLst/>
+          </a:prstGeom>
+          <a:solidFill>
+            <a:srgbClr val="FFFFFF"/>
+          </a:solidFill>
+          <a:ln w="9525">
+            <a:solidFill>
+              <a:srgbClr val="3674C1"/>
+            </a:solidFill>
+            <a:prstDash val="dash"/>
+          </a:ln>
+        </p:spPr>
+      </p:sp>
+      <p:sp>
+        <p:nvSpPr>
+          <p:cNvPr id="7" name="Text 5"/>
+          <p:cNvSpPr/>
+          <p:nvPr/>
+        </p:nvSpPr>
+        <p:spPr>
+          <a:xfrm>
+            <a:off x="10264140" y="1536192"/>
+            <a:ext cx="1234440" cy="1234440"/>
+          </a:xfrm>
+          <a:prstGeom prst="rect">
+            <a:avLst/>
+          </a:prstGeom>
+          <a:noFill/>
+          <a:ln/>
+        </p:spPr>
+        <p:txBody>
+          <a:bodyPr wrap="square" rtlCol="0" anchor="ctr"/>
+          <a:lstStyle/>
+          <a:p>
+            <a:pPr algn="ctr" indent="0" marL="0">
+              <a:buNone/>
+            </a:pPr>
+            <a:r>
+              <a:rPr lang="en-US" sz="1100" dirty="0">
+                <a:solidFill>
+                  <a:srgbClr val="3674C1"/>
+                </a:solidFill>
+                <a:latin typeface="Calibri" pitchFamily="34" charset="0"/>
+                <a:ea typeface="Calibri" pitchFamily="34" charset="-122"/>
+                <a:cs typeface="Calibri" pitchFamily="34" charset="-120"/>
+              </a:rPr>
+              <a:t>QR</a:t>
+            </a:r>
+            <a:endParaRPr lang="en-US" sz="1100" dirty="0"/>
+          </a:p>
+        </p:txBody>
+      </p:sp>
+      <p:sp>
+        <p:nvSpPr>
+          <p:cNvPr id="8" name="Text 6">
+            <a:hlinkClick r:id="rId1" tooltip=""/>
+          </p:cNvPr>
+          <p:cNvSpPr/>
+          <p:nvPr/>
+        </p:nvSpPr>
+        <p:spPr>
+          <a:xfrm>
+            <a:off x="10140696" y="2807208"/>
+            <a:ext cx="1481328" cy="310896"/>
+          </a:xfrm>
+          <a:prstGeom prst="rect">
+            <a:avLst/>
+          </a:prstGeom>
+          <a:noFill/>
+          <a:ln/>
+        </p:spPr>
+        <p:txBody>
+          <a:bodyPr wrap="square" rtlCol="0" anchor="ctr"/>
+          <a:lstStyle/>
+          <a:p>
+            <a:pPr algn="ctr" indent="0" marL="0">
+              <a:buNone/>
+            </a:pPr>
+            <a:r>
+              <a:rPr lang="en-US" sz="750" u="sng" dirty="0">
+                <a:solidFill>
+                  <a:srgbClr val="5A6675"/>
+                </a:solidFill>
+                <a:latin typeface="Calibri" pitchFamily="34" charset="0"/>
+                <a:ea typeface="Calibri" pitchFamily="34" charset="-122"/>
+                <a:cs typeface="Calibri" pitchFamily="34" charset="-120"/>
+                <a:hlinkClick r:id="rId1" invalidUrl="" action="" tgtFrame="" tooltip="" history="1" highlightClick="0" endSnd="0">
+                  <a:extLst>
+                    <a:ext uri="{A12FA001-AC4F-418D-AE19-62706E023703}">
+                      <ahyp:hlinkClr xmlns:ahyp="http://schemas.microsoft.com/office/drawing/2018/hyperlinkcolor" val="tx"/>
+                    </a:ext>
+                  </a:extLst>
+                </a:hlinkClick>
+              </a:rPr>
+              <a:t>github.com/uw-loci/qupath-extension-tiles-to-pyramid</a:t>
+            </a:r>
+            <a:endParaRPr lang="en-US" sz="750" dirty="0"/>
+          </a:p>
+        </p:txBody>
+      </p:sp>
+      <p:sp>
+        <p:nvSpPr>
+          <p:cNvPr id="9" name="Text 7"/>
+          <p:cNvSpPr/>
+          <p:nvPr/>
+        </p:nvSpPr>
+        <p:spPr>
+          <a:xfrm>
             <a:off x="640080" y="1755648"/>
-            <a:ext cx="10963656" cy="4279392"/>
+            <a:ext cx="9226296" cy="4279392"/>
           </a:xfrm>
           <a:prstGeom prst="rect">
             <a:avLst/>
@@ -9847,7 +10561,7 @@
       </p:sp>
       <p:sp>
         <p:nvSpPr>
-          <p:cNvPr id="6" name="Shape 4"/>
+          <p:cNvPr id="10" name="Shape 8"/>
           <p:cNvSpPr/>
           <p:nvPr/>
         </p:nvSpPr>
@@ -9872,7 +10586,7 @@
       </p:sp>
       <p:sp>
         <p:nvSpPr>
-          <p:cNvPr id="7" name="Text 5"/>
+          <p:cNvPr id="11" name="Text 9"/>
           <p:cNvSpPr/>
           <p:nvPr/>
         </p:nvSpPr>
@@ -9911,7 +10625,7 @@
       </p:sp>
       <p:sp>
         <p:nvSpPr>
-          <p:cNvPr id="8" name="Text 6"/>
+          <p:cNvPr id="12" name="Text 10"/>
           <p:cNvSpPr/>
           <p:nvPr/>
         </p:nvSpPr>
@@ -10986,8 +11700,159 @@
         </p:nvSpPr>
         <p:spPr>
           <a:xfrm>
+            <a:off x="10140696" y="1316736"/>
+            <a:ext cx="1481328" cy="201168"/>
+          </a:xfrm>
+          <a:prstGeom prst="rect">
+            <a:avLst/>
+          </a:prstGeom>
+          <a:noFill/>
+          <a:ln/>
+        </p:spPr>
+        <p:txBody>
+          <a:bodyPr wrap="square" rtlCol="0" anchor="ctr"/>
+          <a:lstStyle/>
+          <a:p>
+            <a:pPr algn="ctr" indent="0" marL="0">
+              <a:buNone/>
+            </a:pPr>
+            <a:r>
+              <a:rPr lang="en-US" sz="1000" b="1" dirty="0">
+                <a:solidFill>
+                  <a:srgbClr val="1F4C86"/>
+                </a:solidFill>
+                <a:latin typeface="Calibri" pitchFamily="34" charset="0"/>
+                <a:ea typeface="Calibri" pitchFamily="34" charset="-122"/>
+                <a:cs typeface="Calibri" pitchFamily="34" charset="-120"/>
+              </a:rPr>
+              <a:t>DL Pixel Classifier</a:t>
+            </a:r>
+            <a:endParaRPr lang="en-US" sz="1000" dirty="0"/>
+          </a:p>
+        </p:txBody>
+      </p:sp>
+      <p:sp>
+        <p:nvSpPr>
+          <p:cNvPr id="6" name="Shape 4"/>
+          <p:cNvSpPr/>
+          <p:nvPr/>
+        </p:nvSpPr>
+        <p:spPr>
+          <a:xfrm>
+            <a:off x="10264140" y="1536192"/>
+            <a:ext cx="1234440" cy="1234440"/>
+          </a:xfrm>
+          <a:prstGeom prst="rect">
+            <a:avLst/>
+          </a:prstGeom>
+          <a:solidFill>
+            <a:srgbClr val="FFFFFF"/>
+          </a:solidFill>
+          <a:ln w="9525">
+            <a:solidFill>
+              <a:srgbClr val="3674C1"/>
+            </a:solidFill>
+            <a:prstDash val="dash"/>
+          </a:ln>
+        </p:spPr>
+      </p:sp>
+      <p:sp>
+        <p:nvSpPr>
+          <p:cNvPr id="7" name="Text 5"/>
+          <p:cNvSpPr/>
+          <p:nvPr/>
+        </p:nvSpPr>
+        <p:spPr>
+          <a:xfrm>
+            <a:off x="10264140" y="1536192"/>
+            <a:ext cx="1234440" cy="1234440"/>
+          </a:xfrm>
+          <a:prstGeom prst="rect">
+            <a:avLst/>
+          </a:prstGeom>
+          <a:noFill/>
+          <a:ln/>
+        </p:spPr>
+        <p:txBody>
+          <a:bodyPr wrap="square" rtlCol="0" anchor="ctr"/>
+          <a:lstStyle/>
+          <a:p>
+            <a:pPr algn="ctr" indent="0" marL="0">
+              <a:buNone/>
+            </a:pPr>
+            <a:r>
+              <a:rPr lang="en-US" sz="1100" dirty="0">
+                <a:solidFill>
+                  <a:srgbClr val="3674C1"/>
+                </a:solidFill>
+                <a:latin typeface="Calibri" pitchFamily="34" charset="0"/>
+                <a:ea typeface="Calibri" pitchFamily="34" charset="-122"/>
+                <a:cs typeface="Calibri" pitchFamily="34" charset="-120"/>
+              </a:rPr>
+              <a:t>QR</a:t>
+            </a:r>
+            <a:endParaRPr lang="en-US" sz="1100" dirty="0"/>
+          </a:p>
+        </p:txBody>
+      </p:sp>
+      <p:sp>
+        <p:nvSpPr>
+          <p:cNvPr id="8" name="Text 6">
+            <a:hlinkClick r:id="rId1" tooltip=""/>
+          </p:cNvPr>
+          <p:cNvSpPr/>
+          <p:nvPr/>
+        </p:nvSpPr>
+        <p:spPr>
+          <a:xfrm>
+            <a:off x="10140696" y="2807208"/>
+            <a:ext cx="1481328" cy="310896"/>
+          </a:xfrm>
+          <a:prstGeom prst="rect">
+            <a:avLst/>
+          </a:prstGeom>
+          <a:noFill/>
+          <a:ln/>
+        </p:spPr>
+        <p:txBody>
+          <a:bodyPr wrap="square" rtlCol="0" anchor="ctr"/>
+          <a:lstStyle/>
+          <a:p>
+            <a:pPr algn="ctr" indent="0" marL="0">
+              <a:buNone/>
+            </a:pPr>
+            <a:r>
+              <a:rPr lang="en-US" sz="750" u="sng" dirty="0">
+                <a:solidFill>
+                  <a:srgbClr val="5A6675"/>
+                </a:solidFill>
+                <a:latin typeface="Calibri" pitchFamily="34" charset="0"/>
+                <a:ea typeface="Calibri" pitchFamily="34" charset="-122"/>
+                <a:cs typeface="Calibri" pitchFamily="34" charset="-120"/>
+                <a:hlinkClick r:id="rId1" invalidUrl="" action="" tgtFrame="" tooltip="" history="1" highlightClick="0" endSnd="0">
+                  <a:extLst>
+                    <a:ext uri="{A12FA001-AC4F-418D-AE19-62706E023703}">
+                      <ahyp:hlinkClr xmlns:ahyp="http://schemas.microsoft.com/office/drawing/2018/hyperlinkcolor" val="tx"/>
+                    </a:ext>
+                  </a:extLst>
+                </a:hlinkClick>
+              </a:rPr>
+              <a:t>github.com/uw-loci/qupath-extension-dl-pixel-classifier</a:t>
+            </a:r>
+            <a:endParaRPr lang="en-US" sz="750" dirty="0"/>
+          </a:p>
+        </p:txBody>
+      </p:sp>
+      <p:sp>
+        <p:nvSpPr>
+          <p:cNvPr id="9" name="Text 7"/>
+          <p:cNvSpPr/>
+          <p:nvPr/>
+        </p:nvSpPr>
+        <p:spPr>
+          <a:xfrm>
             <a:off x="640080" y="1755648"/>
-            <a:ext cx="10963656" cy="4279392"/>
+            <a:ext cx="9226296" cy="4279392"/>
           </a:xfrm>
           <a:prstGeom prst="rect">
             <a:avLst/>
@@ -11098,7 +11963,7 @@
       </p:sp>
       <p:sp>
         <p:nvSpPr>
-          <p:cNvPr id="6" name="Text 4"/>
+          <p:cNvPr id="10" name="Text 8"/>
           <p:cNvSpPr/>
           <p:nvPr/>
         </p:nvSpPr>
@@ -11648,8 +12513,310 @@
         </p:nvSpPr>
         <p:spPr>
           <a:xfrm>
+            <a:off x="10140696" y="1316736"/>
+            <a:ext cx="1481328" cy="201168"/>
+          </a:xfrm>
+          <a:prstGeom prst="rect">
+            <a:avLst/>
+          </a:prstGeom>
+          <a:noFill/>
+          <a:ln/>
+        </p:spPr>
+        <p:txBody>
+          <a:bodyPr wrap="square" rtlCol="0" anchor="ctr"/>
+          <a:lstStyle/>
+          <a:p>
+            <a:pPr algn="ctr" indent="0" marL="0">
+              <a:buNone/>
+            </a:pPr>
+            <a:r>
+              <a:rPr lang="en-US" sz="1000" b="1" dirty="0">
+                <a:solidFill>
+                  <a:srgbClr val="1F4C86"/>
+                </a:solidFill>
+                <a:latin typeface="Calibri" pitchFamily="34" charset="0"/>
+                <a:ea typeface="Calibri" pitchFamily="34" charset="-122"/>
+                <a:cs typeface="Calibri" pitchFamily="34" charset="-120"/>
+              </a:rPr>
+              <a:t>QP-CAT</a:t>
+            </a:r>
+            <a:endParaRPr lang="en-US" sz="1000" dirty="0"/>
+          </a:p>
+        </p:txBody>
+      </p:sp>
+      <p:sp>
+        <p:nvSpPr>
+          <p:cNvPr id="6" name="Shape 4"/>
+          <p:cNvSpPr/>
+          <p:nvPr/>
+        </p:nvSpPr>
+        <p:spPr>
+          <a:xfrm>
+            <a:off x="10355580" y="1536192"/>
+            <a:ext cx="1051560" cy="1051560"/>
+          </a:xfrm>
+          <a:prstGeom prst="rect">
+            <a:avLst/>
+          </a:prstGeom>
+          <a:solidFill>
+            <a:srgbClr val="FFFFFF"/>
+          </a:solidFill>
+          <a:ln w="9525">
+            <a:solidFill>
+              <a:srgbClr val="3674C1"/>
+            </a:solidFill>
+            <a:prstDash val="dash"/>
+          </a:ln>
+        </p:spPr>
+      </p:sp>
+      <p:sp>
+        <p:nvSpPr>
+          <p:cNvPr id="7" name="Text 5"/>
+          <p:cNvSpPr/>
+          <p:nvPr/>
+        </p:nvSpPr>
+        <p:spPr>
+          <a:xfrm>
+            <a:off x="10355580" y="1536192"/>
+            <a:ext cx="1051560" cy="1051560"/>
+          </a:xfrm>
+          <a:prstGeom prst="rect">
+            <a:avLst/>
+          </a:prstGeom>
+          <a:noFill/>
+          <a:ln/>
+        </p:spPr>
+        <p:txBody>
+          <a:bodyPr wrap="square" rtlCol="0" anchor="ctr"/>
+          <a:lstStyle/>
+          <a:p>
+            <a:pPr algn="ctr" indent="0" marL="0">
+              <a:buNone/>
+            </a:pPr>
+            <a:r>
+              <a:rPr lang="en-US" sz="1100" dirty="0">
+                <a:solidFill>
+                  <a:srgbClr val="3674C1"/>
+                </a:solidFill>
+                <a:latin typeface="Calibri" pitchFamily="34" charset="0"/>
+                <a:ea typeface="Calibri" pitchFamily="34" charset="-122"/>
+                <a:cs typeface="Calibri" pitchFamily="34" charset="-120"/>
+              </a:rPr>
+              <a:t>QR</a:t>
+            </a:r>
+            <a:endParaRPr lang="en-US" sz="1100" dirty="0"/>
+          </a:p>
+        </p:txBody>
+      </p:sp>
+      <p:sp>
+        <p:nvSpPr>
+          <p:cNvPr id="8" name="Text 6">
+            <a:hlinkClick r:id="rId1" tooltip=""/>
+          </p:cNvPr>
+          <p:cNvSpPr/>
+          <p:nvPr/>
+        </p:nvSpPr>
+        <p:spPr>
+          <a:xfrm>
+            <a:off x="10140696" y="2624328"/>
+            <a:ext cx="1481328" cy="310896"/>
+          </a:xfrm>
+          <a:prstGeom prst="rect">
+            <a:avLst/>
+          </a:prstGeom>
+          <a:noFill/>
+          <a:ln/>
+        </p:spPr>
+        <p:txBody>
+          <a:bodyPr wrap="square" rtlCol="0" anchor="ctr"/>
+          <a:lstStyle/>
+          <a:p>
+            <a:pPr algn="ctr" indent="0" marL="0">
+              <a:buNone/>
+            </a:pPr>
+            <a:r>
+              <a:rPr lang="en-US" sz="750" u="sng" dirty="0">
+                <a:solidFill>
+                  <a:srgbClr val="5A6675"/>
+                </a:solidFill>
+                <a:latin typeface="Calibri" pitchFamily="34" charset="0"/>
+                <a:ea typeface="Calibri" pitchFamily="34" charset="-122"/>
+                <a:cs typeface="Calibri" pitchFamily="34" charset="-120"/>
+                <a:hlinkClick r:id="rId1" invalidUrl="" action="" tgtFrame="" tooltip="" history="1" highlightClick="0" endSnd="0">
+                  <a:extLst>
+                    <a:ext uri="{A12FA001-AC4F-418D-AE19-62706E023703}">
+                      <ahyp:hlinkClr xmlns:ahyp="http://schemas.microsoft.com/office/drawing/2018/hyperlinkcolor" val="tx"/>
+                    </a:ext>
+                  </a:extLst>
+                </a:hlinkClick>
+              </a:rPr>
+              <a:t>github.com/uw-loci/qupath-extension-cell-analysis-tools</a:t>
+            </a:r>
+            <a:endParaRPr lang="en-US" sz="750" dirty="0"/>
+          </a:p>
+        </p:txBody>
+      </p:sp>
+      <p:sp>
+        <p:nvSpPr>
+          <p:cNvPr id="9" name="Text 7"/>
+          <p:cNvSpPr/>
+          <p:nvPr/>
+        </p:nvSpPr>
+        <p:spPr>
+          <a:xfrm>
+            <a:off x="10140696" y="2971800"/>
+            <a:ext cx="1481328" cy="201168"/>
+          </a:xfrm>
+          <a:prstGeom prst="rect">
+            <a:avLst/>
+          </a:prstGeom>
+          <a:noFill/>
+          <a:ln/>
+        </p:spPr>
+        <p:txBody>
+          <a:bodyPr wrap="square" rtlCol="0" anchor="ctr"/>
+          <a:lstStyle/>
+          <a:p>
+            <a:pPr algn="ctr" indent="0" marL="0">
+              <a:buNone/>
+            </a:pPr>
+            <a:r>
+              <a:rPr lang="en-US" sz="1000" b="1" dirty="0">
+                <a:solidFill>
+                  <a:srgbClr val="1F4C86"/>
+                </a:solidFill>
+                <a:latin typeface="Calibri" pitchFamily="34" charset="0"/>
+                <a:ea typeface="Calibri" pitchFamily="34" charset="-122"/>
+                <a:cs typeface="Calibri" pitchFamily="34" charset="-120"/>
+              </a:rPr>
+              <a:t>Cluster 3D Nav</a:t>
+            </a:r>
+            <a:endParaRPr lang="en-US" sz="1000" dirty="0"/>
+          </a:p>
+        </p:txBody>
+      </p:sp>
+      <p:sp>
+        <p:nvSpPr>
+          <p:cNvPr id="10" name="Shape 8"/>
+          <p:cNvSpPr/>
+          <p:nvPr/>
+        </p:nvSpPr>
+        <p:spPr>
+          <a:xfrm>
+            <a:off x="10355580" y="3191256"/>
+            <a:ext cx="1051560" cy="1051560"/>
+          </a:xfrm>
+          <a:prstGeom prst="rect">
+            <a:avLst/>
+          </a:prstGeom>
+          <a:solidFill>
+            <a:srgbClr val="FFFFFF"/>
+          </a:solidFill>
+          <a:ln w="9525">
+            <a:solidFill>
+              <a:srgbClr val="3674C1"/>
+            </a:solidFill>
+            <a:prstDash val="dash"/>
+          </a:ln>
+        </p:spPr>
+      </p:sp>
+      <p:sp>
+        <p:nvSpPr>
+          <p:cNvPr id="11" name="Text 9"/>
+          <p:cNvSpPr/>
+          <p:nvPr/>
+        </p:nvSpPr>
+        <p:spPr>
+          <a:xfrm>
+            <a:off x="10355580" y="3191256"/>
+            <a:ext cx="1051560" cy="1051560"/>
+          </a:xfrm>
+          <a:prstGeom prst="rect">
+            <a:avLst/>
+          </a:prstGeom>
+          <a:noFill/>
+          <a:ln/>
+        </p:spPr>
+        <p:txBody>
+          <a:bodyPr wrap="square" rtlCol="0" anchor="ctr"/>
+          <a:lstStyle/>
+          <a:p>
+            <a:pPr algn="ctr" indent="0" marL="0">
+              <a:buNone/>
+            </a:pPr>
+            <a:r>
+              <a:rPr lang="en-US" sz="1100" dirty="0">
+                <a:solidFill>
+                  <a:srgbClr val="3674C1"/>
+                </a:solidFill>
+                <a:latin typeface="Calibri" pitchFamily="34" charset="0"/>
+                <a:ea typeface="Calibri" pitchFamily="34" charset="-122"/>
+                <a:cs typeface="Calibri" pitchFamily="34" charset="-120"/>
+              </a:rPr>
+              <a:t>QR</a:t>
+            </a:r>
+            <a:endParaRPr lang="en-US" sz="1100" dirty="0"/>
+          </a:p>
+        </p:txBody>
+      </p:sp>
+      <p:sp>
+        <p:nvSpPr>
+          <p:cNvPr id="12" name="Text 10">
+            <a:hlinkClick r:id="rId2" tooltip=""/>
+          </p:cNvPr>
+          <p:cNvSpPr/>
+          <p:nvPr/>
+        </p:nvSpPr>
+        <p:spPr>
+          <a:xfrm>
+            <a:off x="10140696" y="4279392"/>
+            <a:ext cx="1481328" cy="310896"/>
+          </a:xfrm>
+          <a:prstGeom prst="rect">
+            <a:avLst/>
+          </a:prstGeom>
+          <a:noFill/>
+          <a:ln/>
+        </p:spPr>
+        <p:txBody>
+          <a:bodyPr wrap="square" rtlCol="0" anchor="ctr"/>
+          <a:lstStyle/>
+          <a:p>
+            <a:pPr algn="ctr" indent="0" marL="0">
+              <a:buNone/>
+            </a:pPr>
+            <a:r>
+              <a:rPr lang="en-US" sz="750" u="sng" dirty="0">
+                <a:solidFill>
+                  <a:srgbClr val="5A6675"/>
+                </a:solidFill>
+                <a:latin typeface="Calibri" pitchFamily="34" charset="0"/>
+                <a:ea typeface="Calibri" pitchFamily="34" charset="-122"/>
+                <a:cs typeface="Calibri" pitchFamily="34" charset="-120"/>
+                <a:hlinkClick r:id="rId2" invalidUrl="" action="" tgtFrame="" tooltip="" history="1" highlightClick="0" endSnd="0">
+                  <a:extLst>
+                    <a:ext uri="{A12FA001-AC4F-418D-AE19-62706E023703}">
+                      <ahyp:hlinkClr xmlns:ahyp="http://schemas.microsoft.com/office/drawing/2018/hyperlinkcolor" val="tx"/>
+                    </a:ext>
+                  </a:extLst>
+                </a:hlinkClick>
+              </a:rPr>
+              <a:t>github.com/uw-loci/qupath-extension-cluster-3d-navigator</a:t>
+            </a:r>
+            <a:endParaRPr lang="en-US" sz="750" dirty="0"/>
+          </a:p>
+        </p:txBody>
+      </p:sp>
+      <p:sp>
+        <p:nvSpPr>
+          <p:cNvPr id="13" name="Text 11"/>
+          <p:cNvSpPr/>
+          <p:nvPr/>
+        </p:nvSpPr>
+        <p:spPr>
+          <a:xfrm>
             <a:off x="640080" y="1755648"/>
-            <a:ext cx="10963656" cy="4279392"/>
+            <a:ext cx="9226296" cy="4279392"/>
           </a:xfrm>
           <a:prstGeom prst="rect">
             <a:avLst/>
@@ -11784,7 +12951,7 @@
       </p:sp>
       <p:sp>
         <p:nvSpPr>
-          <p:cNvPr id="6" name="Shape 4"/>
+          <p:cNvPr id="14" name="Shape 12"/>
           <p:cNvSpPr/>
           <p:nvPr/>
         </p:nvSpPr>
@@ -11809,7 +12976,7 @@
       </p:sp>
       <p:sp>
         <p:nvSpPr>
-          <p:cNvPr id="7" name="Text 5"/>
+          <p:cNvPr id="15" name="Text 13"/>
           <p:cNvSpPr/>
           <p:nvPr/>
         </p:nvSpPr>
@@ -11848,7 +13015,7 @@
       </p:sp>
       <p:sp>
         <p:nvSpPr>
-          <p:cNvPr id="8" name="Text 6"/>
+          <p:cNvPr id="16" name="Text 14"/>
           <p:cNvSpPr/>
           <p:nvPr/>
         </p:nvSpPr>
@@ -12971,14 +14138,316 @@
       </p:sp>
       <p:sp>
         <p:nvSpPr>
-          <p:cNvPr id="4" name="Shape 2"/>
+          <p:cNvPr id="4" name="Text 2"/>
+          <p:cNvSpPr/>
+          <p:nvPr/>
+        </p:nvSpPr>
+        <p:spPr>
+          <a:xfrm>
+            <a:off x="10140696" y="1280160"/>
+            <a:ext cx="1481328" cy="201168"/>
+          </a:xfrm>
+          <a:prstGeom prst="rect">
+            <a:avLst/>
+          </a:prstGeom>
+          <a:noFill/>
+          <a:ln/>
+        </p:spPr>
+        <p:txBody>
+          <a:bodyPr wrap="square" rtlCol="0" anchor="ctr"/>
+          <a:lstStyle/>
+          <a:p>
+            <a:pPr algn="ctr" indent="0" marL="0">
+              <a:buNone/>
+            </a:pPr>
+            <a:r>
+              <a:rPr lang="en-US" sz="1000" b="1" dirty="0">
+                <a:solidFill>
+                  <a:srgbClr val="1F4C86"/>
+                </a:solidFill>
+                <a:latin typeface="Calibri" pitchFamily="34" charset="0"/>
+                <a:ea typeface="Calibri" pitchFamily="34" charset="-122"/>
+                <a:cs typeface="Calibri" pitchFamily="34" charset="-120"/>
+              </a:rPr>
+              <a:t>Fiber Analysis</a:t>
+            </a:r>
+            <a:endParaRPr lang="en-US" sz="1000" dirty="0"/>
+          </a:p>
+        </p:txBody>
+      </p:sp>
+      <p:sp>
+        <p:nvSpPr>
+          <p:cNvPr id="5" name="Shape 3"/>
+          <p:cNvSpPr/>
+          <p:nvPr/>
+        </p:nvSpPr>
+        <p:spPr>
+          <a:xfrm>
+            <a:off x="10355580" y="1499616"/>
+            <a:ext cx="1051560" cy="1051560"/>
+          </a:xfrm>
+          <a:prstGeom prst="rect">
+            <a:avLst/>
+          </a:prstGeom>
+          <a:solidFill>
+            <a:srgbClr val="FFFFFF"/>
+          </a:solidFill>
+          <a:ln w="9525">
+            <a:solidFill>
+              <a:srgbClr val="3674C1"/>
+            </a:solidFill>
+            <a:prstDash val="dash"/>
+          </a:ln>
+        </p:spPr>
+      </p:sp>
+      <p:sp>
+        <p:nvSpPr>
+          <p:cNvPr id="6" name="Text 4"/>
+          <p:cNvSpPr/>
+          <p:nvPr/>
+        </p:nvSpPr>
+        <p:spPr>
+          <a:xfrm>
+            <a:off x="10355580" y="1499616"/>
+            <a:ext cx="1051560" cy="1051560"/>
+          </a:xfrm>
+          <a:prstGeom prst="rect">
+            <a:avLst/>
+          </a:prstGeom>
+          <a:noFill/>
+          <a:ln/>
+        </p:spPr>
+        <p:txBody>
+          <a:bodyPr wrap="square" rtlCol="0" anchor="ctr"/>
+          <a:lstStyle/>
+          <a:p>
+            <a:pPr algn="ctr" indent="0" marL="0">
+              <a:buNone/>
+            </a:pPr>
+            <a:r>
+              <a:rPr lang="en-US" sz="1100" dirty="0">
+                <a:solidFill>
+                  <a:srgbClr val="3674C1"/>
+                </a:solidFill>
+                <a:latin typeface="Calibri" pitchFamily="34" charset="0"/>
+                <a:ea typeface="Calibri" pitchFamily="34" charset="-122"/>
+                <a:cs typeface="Calibri" pitchFamily="34" charset="-120"/>
+              </a:rPr>
+              <a:t>QR</a:t>
+            </a:r>
+            <a:endParaRPr lang="en-US" sz="1100" dirty="0"/>
+          </a:p>
+        </p:txBody>
+      </p:sp>
+      <p:sp>
+        <p:nvSpPr>
+          <p:cNvPr id="7" name="Text 5">
+            <a:hlinkClick r:id="rId1" tooltip=""/>
+          </p:cNvPr>
+          <p:cNvSpPr/>
+          <p:nvPr/>
+        </p:nvSpPr>
+        <p:spPr>
+          <a:xfrm>
+            <a:off x="10140696" y="2587752"/>
+            <a:ext cx="1481328" cy="310896"/>
+          </a:xfrm>
+          <a:prstGeom prst="rect">
+            <a:avLst/>
+          </a:prstGeom>
+          <a:noFill/>
+          <a:ln/>
+        </p:spPr>
+        <p:txBody>
+          <a:bodyPr wrap="square" rtlCol="0" anchor="ctr"/>
+          <a:lstStyle/>
+          <a:p>
+            <a:pPr algn="ctr" indent="0" marL="0">
+              <a:buNone/>
+            </a:pPr>
+            <a:r>
+              <a:rPr lang="en-US" sz="750" u="sng" dirty="0">
+                <a:solidFill>
+                  <a:srgbClr val="5A6675"/>
+                </a:solidFill>
+                <a:latin typeface="Calibri" pitchFamily="34" charset="0"/>
+                <a:ea typeface="Calibri" pitchFamily="34" charset="-122"/>
+                <a:cs typeface="Calibri" pitchFamily="34" charset="-120"/>
+                <a:hlinkClick r:id="rId1" invalidUrl="" action="" tgtFrame="" tooltip="" history="1" highlightClick="0" endSnd="0">
+                  <a:extLst>
+                    <a:ext uri="{A12FA001-AC4F-418D-AE19-62706E023703}">
+                      <ahyp:hlinkClr xmlns:ahyp="http://schemas.microsoft.com/office/drawing/2018/hyperlinkcolor" val="tx"/>
+                    </a:ext>
+                  </a:extLst>
+                </a:hlinkClick>
+              </a:rPr>
+              <a:t>github.com/uw-loci/qupath-extension-fiber-analysis</a:t>
+            </a:r>
+            <a:endParaRPr lang="en-US" sz="750" dirty="0"/>
+          </a:p>
+        </p:txBody>
+      </p:sp>
+      <p:sp>
+        <p:nvSpPr>
+          <p:cNvPr id="8" name="Text 6"/>
+          <p:cNvSpPr/>
+          <p:nvPr/>
+        </p:nvSpPr>
+        <p:spPr>
+          <a:xfrm>
+            <a:off x="10140696" y="2935224"/>
+            <a:ext cx="1481328" cy="201168"/>
+          </a:xfrm>
+          <a:prstGeom prst="rect">
+            <a:avLst/>
+          </a:prstGeom>
+          <a:noFill/>
+          <a:ln/>
+        </p:spPr>
+        <p:txBody>
+          <a:bodyPr wrap="square" rtlCol="0" anchor="ctr"/>
+          <a:lstStyle/>
+          <a:p>
+            <a:pPr algn="ctr" indent="0" marL="0">
+              <a:buNone/>
+            </a:pPr>
+            <a:r>
+              <a:rPr lang="en-US" sz="1000" b="1" dirty="0">
+                <a:solidFill>
+                  <a:srgbClr val="1F4C86"/>
+                </a:solidFill>
+                <a:latin typeface="Calibri" pitchFamily="34" charset="0"/>
+                <a:ea typeface="Calibri" pitchFamily="34" charset="-122"/>
+                <a:cs typeface="Calibri" pitchFamily="34" charset="-120"/>
+              </a:rPr>
+              <a:t>TME-Quant</a:t>
+            </a:r>
+            <a:endParaRPr lang="en-US" sz="1000" dirty="0"/>
+          </a:p>
+        </p:txBody>
+      </p:sp>
+      <p:sp>
+        <p:nvSpPr>
+          <p:cNvPr id="9" name="Shape 7"/>
+          <p:cNvSpPr/>
+          <p:nvPr/>
+        </p:nvSpPr>
+        <p:spPr>
+          <a:xfrm>
+            <a:off x="10355580" y="3154680"/>
+            <a:ext cx="1051560" cy="1051560"/>
+          </a:xfrm>
+          <a:prstGeom prst="rect">
+            <a:avLst/>
+          </a:prstGeom>
+          <a:solidFill>
+            <a:srgbClr val="FFFFFF"/>
+          </a:solidFill>
+          <a:ln w="9525">
+            <a:solidFill>
+              <a:srgbClr val="3674C1"/>
+            </a:solidFill>
+            <a:prstDash val="dash"/>
+          </a:ln>
+        </p:spPr>
+      </p:sp>
+      <p:sp>
+        <p:nvSpPr>
+          <p:cNvPr id="10" name="Text 8"/>
+          <p:cNvSpPr/>
+          <p:nvPr/>
+        </p:nvSpPr>
+        <p:spPr>
+          <a:xfrm>
+            <a:off x="10355580" y="3154680"/>
+            <a:ext cx="1051560" cy="1051560"/>
+          </a:xfrm>
+          <a:prstGeom prst="rect">
+            <a:avLst/>
+          </a:prstGeom>
+          <a:noFill/>
+          <a:ln/>
+        </p:spPr>
+        <p:txBody>
+          <a:bodyPr wrap="square" rtlCol="0" anchor="ctr"/>
+          <a:lstStyle/>
+          <a:p>
+            <a:pPr algn="ctr" indent="0" marL="0">
+              <a:buNone/>
+            </a:pPr>
+            <a:r>
+              <a:rPr lang="en-US" sz="1100" dirty="0">
+                <a:solidFill>
+                  <a:srgbClr val="3674C1"/>
+                </a:solidFill>
+                <a:latin typeface="Calibri" pitchFamily="34" charset="0"/>
+                <a:ea typeface="Calibri" pitchFamily="34" charset="-122"/>
+                <a:cs typeface="Calibri" pitchFamily="34" charset="-120"/>
+              </a:rPr>
+              <a:t>QR</a:t>
+            </a:r>
+            <a:endParaRPr lang="en-US" sz="1100" dirty="0"/>
+          </a:p>
+        </p:txBody>
+      </p:sp>
+      <p:sp>
+        <p:nvSpPr>
+          <p:cNvPr id="11" name="Text 9">
+            <a:hlinkClick r:id="rId2" tooltip=""/>
+          </p:cNvPr>
+          <p:cNvSpPr/>
+          <p:nvPr/>
+        </p:nvSpPr>
+        <p:spPr>
+          <a:xfrm>
+            <a:off x="10140696" y="4242816"/>
+            <a:ext cx="1481328" cy="310896"/>
+          </a:xfrm>
+          <a:prstGeom prst="rect">
+            <a:avLst/>
+          </a:prstGeom>
+          <a:noFill/>
+          <a:ln/>
+        </p:spPr>
+        <p:txBody>
+          <a:bodyPr wrap="square" rtlCol="0" anchor="ctr"/>
+          <a:lstStyle/>
+          <a:p>
+            <a:pPr algn="ctr" indent="0" marL="0">
+              <a:buNone/>
+            </a:pPr>
+            <a:r>
+              <a:rPr lang="en-US" sz="750" u="sng" dirty="0">
+                <a:solidFill>
+                  <a:srgbClr val="5A6675"/>
+                </a:solidFill>
+                <a:latin typeface="Calibri" pitchFamily="34" charset="0"/>
+                <a:ea typeface="Calibri" pitchFamily="34" charset="-122"/>
+                <a:cs typeface="Calibri" pitchFamily="34" charset="-120"/>
+                <a:hlinkClick r:id="rId2" invalidUrl="" action="" tgtFrame="" tooltip="" history="1" highlightClick="0" endSnd="0">
+                  <a:extLst>
+                    <a:ext uri="{A12FA001-AC4F-418D-AE19-62706E023703}">
+                      <ahyp:hlinkClr xmlns:ahyp="http://schemas.microsoft.com/office/drawing/2018/hyperlinkcolor" val="tx"/>
+                    </a:ext>
+                  </a:extLst>
+                </a:hlinkClick>
+              </a:rPr>
+              <a:t>github.com/MichaelSNelson/qupath-extension-TME-Quant</a:t>
+            </a:r>
+            <a:endParaRPr lang="en-US" sz="750" dirty="0"/>
+          </a:p>
+        </p:txBody>
+      </p:sp>
+      <p:sp>
+        <p:nvSpPr>
+          <p:cNvPr id="12" name="Shape 10"/>
           <p:cNvSpPr/>
           <p:nvPr/>
         </p:nvSpPr>
         <p:spPr>
           <a:xfrm>
             <a:off x="566928" y="1554480"/>
-            <a:ext cx="5298948" cy="530352"/>
+            <a:ext cx="4430268" cy="530352"/>
           </a:xfrm>
           <a:prstGeom prst="rect">
             <a:avLst/>
@@ -12991,14 +14460,14 @@
       </p:sp>
       <p:sp>
         <p:nvSpPr>
-          <p:cNvPr id="5" name="Text 3"/>
+          <p:cNvPr id="13" name="Text 11"/>
           <p:cNvSpPr/>
           <p:nvPr/>
         </p:nvSpPr>
         <p:spPr>
           <a:xfrm>
             <a:off x="731520" y="1554480"/>
-            <a:ext cx="4969764" cy="530352"/>
+            <a:ext cx="4101084" cy="530352"/>
           </a:xfrm>
           <a:prstGeom prst="rect">
             <a:avLst/>
@@ -13030,14 +14499,14 @@
       </p:sp>
       <p:sp>
         <p:nvSpPr>
-          <p:cNvPr id="6" name="Text 4"/>
+          <p:cNvPr id="14" name="Text 12"/>
           <p:cNvSpPr/>
           <p:nvPr/>
         </p:nvSpPr>
         <p:spPr>
           <a:xfrm>
             <a:off x="658368" y="2240280"/>
-            <a:ext cx="5116068" cy="3566160"/>
+            <a:ext cx="4247388" cy="3566160"/>
           </a:xfrm>
           <a:prstGeom prst="rect">
             <a:avLst/>
@@ -13136,14 +14605,14 @@
       </p:sp>
       <p:sp>
         <p:nvSpPr>
-          <p:cNvPr id="7" name="Shape 5"/>
-          <p:cNvSpPr/>
-          <p:nvPr/>
-        </p:nvSpPr>
-        <p:spPr>
-          <a:xfrm>
-            <a:off x="6323076" y="1554480"/>
-            <a:ext cx="5298948" cy="530352"/>
+          <p:cNvPr id="15" name="Shape 13"/>
+          <p:cNvSpPr/>
+          <p:nvPr/>
+        </p:nvSpPr>
+        <p:spPr>
+          <a:xfrm>
+            <a:off x="5454396" y="1554480"/>
+            <a:ext cx="4430268" cy="530352"/>
           </a:xfrm>
           <a:prstGeom prst="rect">
             <a:avLst/>
@@ -13156,14 +14625,14 @@
       </p:sp>
       <p:sp>
         <p:nvSpPr>
-          <p:cNvPr id="8" name="Text 6"/>
-          <p:cNvSpPr/>
-          <p:nvPr/>
-        </p:nvSpPr>
-        <p:spPr>
-          <a:xfrm>
-            <a:off x="6487668" y="1554480"/>
-            <a:ext cx="4969764" cy="530352"/>
+          <p:cNvPr id="16" name="Text 14"/>
+          <p:cNvSpPr/>
+          <p:nvPr/>
+        </p:nvSpPr>
+        <p:spPr>
+          <a:xfrm>
+            <a:off x="5618988" y="1554480"/>
+            <a:ext cx="4101084" cy="530352"/>
           </a:xfrm>
           <a:prstGeom prst="rect">
             <a:avLst/>
@@ -13195,14 +14664,14 @@
       </p:sp>
       <p:sp>
         <p:nvSpPr>
-          <p:cNvPr id="9" name="Text 7"/>
-          <p:cNvSpPr/>
-          <p:nvPr/>
-        </p:nvSpPr>
-        <p:spPr>
-          <a:xfrm>
-            <a:off x="6414516" y="2240280"/>
-            <a:ext cx="5116068" cy="3566160"/>
+          <p:cNvPr id="17" name="Text 15"/>
+          <p:cNvSpPr/>
+          <p:nvPr/>
+        </p:nvSpPr>
+        <p:spPr>
+          <a:xfrm>
+            <a:off x="5545836" y="2240280"/>
+            <a:ext cx="4247388" cy="3566160"/>
           </a:xfrm>
           <a:prstGeom prst="rect">
             <a:avLst/>
@@ -13301,7 +14770,7 @@
       </p:sp>
       <p:sp>
         <p:nvSpPr>
-          <p:cNvPr id="10" name="Text 8"/>
+          <p:cNvPr id="18" name="Text 16"/>
           <p:cNvSpPr/>
           <p:nvPr/>
         </p:nvSpPr>
@@ -14040,8 +15509,159 @@
         </p:nvSpPr>
         <p:spPr>
           <a:xfrm>
+            <a:off x="10140696" y="1280160"/>
+            <a:ext cx="1481328" cy="201168"/>
+          </a:xfrm>
+          <a:prstGeom prst="rect">
+            <a:avLst/>
+          </a:prstGeom>
+          <a:noFill/>
+          <a:ln/>
+        </p:spPr>
+        <p:txBody>
+          <a:bodyPr wrap="square" rtlCol="0" anchor="ctr"/>
+          <a:lstStyle/>
+          <a:p>
+            <a:pPr algn="ctr" indent="0" marL="0">
+              <a:buNone/>
+            </a:pPr>
+            <a:r>
+              <a:rPr lang="en-US" sz="1000" b="1" dirty="0">
+                <a:solidFill>
+                  <a:srgbClr val="1F4C86"/>
+                </a:solidFill>
+                <a:latin typeface="Calibri" pitchFamily="34" charset="0"/>
+                <a:ea typeface="Calibri" pitchFamily="34" charset="-122"/>
+                <a:cs typeface="Calibri" pitchFamily="34" charset="-120"/>
+              </a:rPr>
+              <a:t>QPSC</a:t>
+            </a:r>
+            <a:endParaRPr lang="en-US" sz="1000" dirty="0"/>
+          </a:p>
+        </p:txBody>
+      </p:sp>
+      <p:sp>
+        <p:nvSpPr>
+          <p:cNvPr id="5" name="Shape 3"/>
+          <p:cNvSpPr/>
+          <p:nvPr/>
+        </p:nvSpPr>
+        <p:spPr>
+          <a:xfrm>
+            <a:off x="10264140" y="1499616"/>
+            <a:ext cx="1234440" cy="1234440"/>
+          </a:xfrm>
+          <a:prstGeom prst="rect">
+            <a:avLst/>
+          </a:prstGeom>
+          <a:solidFill>
+            <a:srgbClr val="FFFFFF"/>
+          </a:solidFill>
+          <a:ln w="9525">
+            <a:solidFill>
+              <a:srgbClr val="3674C1"/>
+            </a:solidFill>
+            <a:prstDash val="dash"/>
+          </a:ln>
+        </p:spPr>
+      </p:sp>
+      <p:sp>
+        <p:nvSpPr>
+          <p:cNvPr id="6" name="Text 4"/>
+          <p:cNvSpPr/>
+          <p:nvPr/>
+        </p:nvSpPr>
+        <p:spPr>
+          <a:xfrm>
+            <a:off x="10264140" y="1499616"/>
+            <a:ext cx="1234440" cy="1234440"/>
+          </a:xfrm>
+          <a:prstGeom prst="rect">
+            <a:avLst/>
+          </a:prstGeom>
+          <a:noFill/>
+          <a:ln/>
+        </p:spPr>
+        <p:txBody>
+          <a:bodyPr wrap="square" rtlCol="0" anchor="ctr"/>
+          <a:lstStyle/>
+          <a:p>
+            <a:pPr algn="ctr" indent="0" marL="0">
+              <a:buNone/>
+            </a:pPr>
+            <a:r>
+              <a:rPr lang="en-US" sz="1100" dirty="0">
+                <a:solidFill>
+                  <a:srgbClr val="3674C1"/>
+                </a:solidFill>
+                <a:latin typeface="Calibri" pitchFamily="34" charset="0"/>
+                <a:ea typeface="Calibri" pitchFamily="34" charset="-122"/>
+                <a:cs typeface="Calibri" pitchFamily="34" charset="-120"/>
+              </a:rPr>
+              <a:t>QR</a:t>
+            </a:r>
+            <a:endParaRPr lang="en-US" sz="1100" dirty="0"/>
+          </a:p>
+        </p:txBody>
+      </p:sp>
+      <p:sp>
+        <p:nvSpPr>
+          <p:cNvPr id="7" name="Text 5">
+            <a:hlinkClick r:id="rId1" tooltip=""/>
+          </p:cNvPr>
+          <p:cNvSpPr/>
+          <p:nvPr/>
+        </p:nvSpPr>
+        <p:spPr>
+          <a:xfrm>
+            <a:off x="10140696" y="2770632"/>
+            <a:ext cx="1481328" cy="310896"/>
+          </a:xfrm>
+          <a:prstGeom prst="rect">
+            <a:avLst/>
+          </a:prstGeom>
+          <a:noFill/>
+          <a:ln/>
+        </p:spPr>
+        <p:txBody>
+          <a:bodyPr wrap="square" rtlCol="0" anchor="ctr"/>
+          <a:lstStyle/>
+          <a:p>
+            <a:pPr algn="ctr" indent="0" marL="0">
+              <a:buNone/>
+            </a:pPr>
+            <a:r>
+              <a:rPr lang="en-US" sz="750" u="sng" dirty="0">
+                <a:solidFill>
+                  <a:srgbClr val="5A6675"/>
+                </a:solidFill>
+                <a:latin typeface="Calibri" pitchFamily="34" charset="0"/>
+                <a:ea typeface="Calibri" pitchFamily="34" charset="-122"/>
+                <a:cs typeface="Calibri" pitchFamily="34" charset="-120"/>
+                <a:hlinkClick r:id="rId1" invalidUrl="" action="" tgtFrame="" tooltip="" history="1" highlightClick="0" endSnd="0">
+                  <a:extLst>
+                    <a:ext uri="{A12FA001-AC4F-418D-AE19-62706E023703}">
+                      <ahyp:hlinkClr xmlns:ahyp="http://schemas.microsoft.com/office/drawing/2018/hyperlinkcolor" val="tx"/>
+                    </a:ext>
+                  </a:extLst>
+                </a:hlinkClick>
+              </a:rPr>
+              <a:t>github.com/uw-loci/qupath-extension-qpsc</a:t>
+            </a:r>
+            <a:endParaRPr lang="en-US" sz="750" dirty="0"/>
+          </a:p>
+        </p:txBody>
+      </p:sp>
+      <p:sp>
+        <p:nvSpPr>
+          <p:cNvPr id="8" name="Text 6"/>
+          <p:cNvSpPr/>
+          <p:nvPr/>
+        </p:nvSpPr>
+        <p:spPr>
+          <a:xfrm>
             <a:off x="640080" y="1481328"/>
-            <a:ext cx="10963656" cy="4553712"/>
+            <a:ext cx="9226296" cy="4553712"/>
           </a:xfrm>
           <a:prstGeom prst="rect">
             <a:avLst/>
@@ -14152,7 +15772,7 @@
       </p:sp>
       <p:sp>
         <p:nvSpPr>
-          <p:cNvPr id="5" name="Text 3"/>
+          <p:cNvPr id="9" name="Text 7"/>
           <p:cNvSpPr/>
           <p:nvPr/>
         </p:nvSpPr>
@@ -19076,8 +20696,461 @@
         </p:nvSpPr>
         <p:spPr>
           <a:xfrm>
+            <a:off x="10140696" y="1316736"/>
+            <a:ext cx="1481328" cy="201168"/>
+          </a:xfrm>
+          <a:prstGeom prst="rect">
+            <a:avLst/>
+          </a:prstGeom>
+          <a:noFill/>
+          <a:ln/>
+        </p:spPr>
+        <p:txBody>
+          <a:bodyPr wrap="square" rtlCol="0" anchor="ctr"/>
+          <a:lstStyle/>
+          <a:p>
+            <a:pPr algn="ctr" indent="0" marL="0">
+              <a:buNone/>
+            </a:pPr>
+            <a:r>
+              <a:rPr lang="en-US" sz="1000" b="1" dirty="0">
+                <a:solidFill>
+                  <a:srgbClr val="1F4C86"/>
+                </a:solidFill>
+                <a:latin typeface="Calibri" pitchFamily="34" charset="0"/>
+                <a:ea typeface="Calibri" pitchFamily="34" charset="-122"/>
+                <a:cs typeface="Calibri" pitchFamily="34" charset="-120"/>
+              </a:rPr>
+              <a:t>Dialog Manager</a:t>
+            </a:r>
+            <a:endParaRPr lang="en-US" sz="1000" dirty="0"/>
+          </a:p>
+        </p:txBody>
+      </p:sp>
+      <p:sp>
+        <p:nvSpPr>
+          <p:cNvPr id="6" name="Shape 4"/>
+          <p:cNvSpPr/>
+          <p:nvPr/>
+        </p:nvSpPr>
+        <p:spPr>
+          <a:xfrm>
+            <a:off x="10479024" y="1536192"/>
+            <a:ext cx="804672" cy="804672"/>
+          </a:xfrm>
+          <a:prstGeom prst="rect">
+            <a:avLst/>
+          </a:prstGeom>
+          <a:solidFill>
+            <a:srgbClr val="FFFFFF"/>
+          </a:solidFill>
+          <a:ln w="9525">
+            <a:solidFill>
+              <a:srgbClr val="3674C1"/>
+            </a:solidFill>
+            <a:prstDash val="dash"/>
+          </a:ln>
+        </p:spPr>
+      </p:sp>
+      <p:sp>
+        <p:nvSpPr>
+          <p:cNvPr id="7" name="Text 5"/>
+          <p:cNvSpPr/>
+          <p:nvPr/>
+        </p:nvSpPr>
+        <p:spPr>
+          <a:xfrm>
+            <a:off x="10479024" y="1536192"/>
+            <a:ext cx="804672" cy="804672"/>
+          </a:xfrm>
+          <a:prstGeom prst="rect">
+            <a:avLst/>
+          </a:prstGeom>
+          <a:noFill/>
+          <a:ln/>
+        </p:spPr>
+        <p:txBody>
+          <a:bodyPr wrap="square" rtlCol="0" anchor="ctr"/>
+          <a:lstStyle/>
+          <a:p>
+            <a:pPr algn="ctr" indent="0" marL="0">
+              <a:buNone/>
+            </a:pPr>
+            <a:r>
+              <a:rPr lang="en-US" sz="1100" dirty="0">
+                <a:solidFill>
+                  <a:srgbClr val="3674C1"/>
+                </a:solidFill>
+                <a:latin typeface="Calibri" pitchFamily="34" charset="0"/>
+                <a:ea typeface="Calibri" pitchFamily="34" charset="-122"/>
+                <a:cs typeface="Calibri" pitchFamily="34" charset="-120"/>
+              </a:rPr>
+              <a:t>QR</a:t>
+            </a:r>
+            <a:endParaRPr lang="en-US" sz="1100" dirty="0"/>
+          </a:p>
+        </p:txBody>
+      </p:sp>
+      <p:sp>
+        <p:nvSpPr>
+          <p:cNvPr id="8" name="Text 6">
+            <a:hlinkClick r:id="rId1" tooltip=""/>
+          </p:cNvPr>
+          <p:cNvSpPr/>
+          <p:nvPr/>
+        </p:nvSpPr>
+        <p:spPr>
+          <a:xfrm>
+            <a:off x="10140696" y="2377440"/>
+            <a:ext cx="1481328" cy="310896"/>
+          </a:xfrm>
+          <a:prstGeom prst="rect">
+            <a:avLst/>
+          </a:prstGeom>
+          <a:noFill/>
+          <a:ln/>
+        </p:spPr>
+        <p:txBody>
+          <a:bodyPr wrap="square" rtlCol="0" anchor="ctr"/>
+          <a:lstStyle/>
+          <a:p>
+            <a:pPr algn="ctr" indent="0" marL="0">
+              <a:buNone/>
+            </a:pPr>
+            <a:r>
+              <a:rPr lang="en-US" sz="750" u="sng" dirty="0">
+                <a:solidFill>
+                  <a:srgbClr val="5A6675"/>
+                </a:solidFill>
+                <a:latin typeface="Calibri" pitchFamily="34" charset="0"/>
+                <a:ea typeface="Calibri" pitchFamily="34" charset="-122"/>
+                <a:cs typeface="Calibri" pitchFamily="34" charset="-120"/>
+                <a:hlinkClick r:id="rId1" invalidUrl="" action="" tgtFrame="" tooltip="" history="1" highlightClick="0" endSnd="0">
+                  <a:extLst>
+                    <a:ext uri="{A12FA001-AC4F-418D-AE19-62706E023703}">
+                      <ahyp:hlinkClr xmlns:ahyp="http://schemas.microsoft.com/office/drawing/2018/hyperlinkcolor" val="tx"/>
+                    </a:ext>
+                  </a:extLst>
+                </a:hlinkClick>
+              </a:rPr>
+              <a:t>github.com/uw-loci/qupath-extension-dialog-manager</a:t>
+            </a:r>
+            <a:endParaRPr lang="en-US" sz="750" dirty="0"/>
+          </a:p>
+        </p:txBody>
+      </p:sp>
+      <p:sp>
+        <p:nvSpPr>
+          <p:cNvPr id="9" name="Text 7"/>
+          <p:cNvSpPr/>
+          <p:nvPr/>
+        </p:nvSpPr>
+        <p:spPr>
+          <a:xfrm>
+            <a:off x="10140696" y="2651760"/>
+            <a:ext cx="1481328" cy="201168"/>
+          </a:xfrm>
+          <a:prstGeom prst="rect">
+            <a:avLst/>
+          </a:prstGeom>
+          <a:noFill/>
+          <a:ln/>
+        </p:spPr>
+        <p:txBody>
+          <a:bodyPr wrap="square" rtlCol="0" anchor="ctr"/>
+          <a:lstStyle/>
+          <a:p>
+            <a:pPr algn="ctr" indent="0" marL="0">
+              <a:buNone/>
+            </a:pPr>
+            <a:r>
+              <a:rPr lang="en-US" sz="1000" b="1" dirty="0">
+                <a:solidFill>
+                  <a:srgbClr val="1F4C86"/>
+                </a:solidFill>
+                <a:latin typeface="Calibri" pitchFamily="34" charset="0"/>
+                <a:ea typeface="Calibri" pitchFamily="34" charset="-122"/>
+                <a:cs typeface="Calibri" pitchFamily="34" charset="-120"/>
+              </a:rPr>
+              <a:t>Channel Names</a:t>
+            </a:r>
+            <a:endParaRPr lang="en-US" sz="1000" dirty="0"/>
+          </a:p>
+        </p:txBody>
+      </p:sp>
+      <p:sp>
+        <p:nvSpPr>
+          <p:cNvPr id="10" name="Shape 8"/>
+          <p:cNvSpPr/>
+          <p:nvPr/>
+        </p:nvSpPr>
+        <p:spPr>
+          <a:xfrm>
+            <a:off x="10479024" y="2871216"/>
+            <a:ext cx="804672" cy="804672"/>
+          </a:xfrm>
+          <a:prstGeom prst="rect">
+            <a:avLst/>
+          </a:prstGeom>
+          <a:solidFill>
+            <a:srgbClr val="FFFFFF"/>
+          </a:solidFill>
+          <a:ln w="9525">
+            <a:solidFill>
+              <a:srgbClr val="3674C1"/>
+            </a:solidFill>
+            <a:prstDash val="dash"/>
+          </a:ln>
+        </p:spPr>
+      </p:sp>
+      <p:sp>
+        <p:nvSpPr>
+          <p:cNvPr id="11" name="Text 9"/>
+          <p:cNvSpPr/>
+          <p:nvPr/>
+        </p:nvSpPr>
+        <p:spPr>
+          <a:xfrm>
+            <a:off x="10479024" y="2871216"/>
+            <a:ext cx="804672" cy="804672"/>
+          </a:xfrm>
+          <a:prstGeom prst="rect">
+            <a:avLst/>
+          </a:prstGeom>
+          <a:noFill/>
+          <a:ln/>
+        </p:spPr>
+        <p:txBody>
+          <a:bodyPr wrap="square" rtlCol="0" anchor="ctr"/>
+          <a:lstStyle/>
+          <a:p>
+            <a:pPr algn="ctr" indent="0" marL="0">
+              <a:buNone/>
+            </a:pPr>
+            <a:r>
+              <a:rPr lang="en-US" sz="1100" dirty="0">
+                <a:solidFill>
+                  <a:srgbClr val="3674C1"/>
+                </a:solidFill>
+                <a:latin typeface="Calibri" pitchFamily="34" charset="0"/>
+                <a:ea typeface="Calibri" pitchFamily="34" charset="-122"/>
+                <a:cs typeface="Calibri" pitchFamily="34" charset="-120"/>
+              </a:rPr>
+              <a:t>QR</a:t>
+            </a:r>
+            <a:endParaRPr lang="en-US" sz="1100" dirty="0"/>
+          </a:p>
+        </p:txBody>
+      </p:sp>
+      <p:sp>
+        <p:nvSpPr>
+          <p:cNvPr id="12" name="Text 10">
+            <a:hlinkClick r:id="rId2" tooltip=""/>
+          </p:cNvPr>
+          <p:cNvSpPr/>
+          <p:nvPr/>
+        </p:nvSpPr>
+        <p:spPr>
+          <a:xfrm>
+            <a:off x="10140696" y="3712464"/>
+            <a:ext cx="1481328" cy="310896"/>
+          </a:xfrm>
+          <a:prstGeom prst="rect">
+            <a:avLst/>
+          </a:prstGeom>
+          <a:noFill/>
+          <a:ln/>
+        </p:spPr>
+        <p:txBody>
+          <a:bodyPr wrap="square" rtlCol="0" anchor="ctr"/>
+          <a:lstStyle/>
+          <a:p>
+            <a:pPr algn="ctr" indent="0" marL="0">
+              <a:buNone/>
+            </a:pPr>
+            <a:r>
+              <a:rPr lang="en-US" sz="750" u="sng" dirty="0">
+                <a:solidFill>
+                  <a:srgbClr val="5A6675"/>
+                </a:solidFill>
+                <a:latin typeface="Calibri" pitchFamily="34" charset="0"/>
+                <a:ea typeface="Calibri" pitchFamily="34" charset="-122"/>
+                <a:cs typeface="Calibri" pitchFamily="34" charset="-120"/>
+                <a:hlinkClick r:id="rId2" invalidUrl="" action="" tgtFrame="" tooltip="" history="1" highlightClick="0" endSnd="0">
+                  <a:extLst>
+                    <a:ext uri="{A12FA001-AC4F-418D-AE19-62706E023703}">
+                      <ahyp:hlinkClr xmlns:ahyp="http://schemas.microsoft.com/office/drawing/2018/hyperlinkcolor" val="tx"/>
+                    </a:ext>
+                  </a:extLst>
+                </a:hlinkClick>
+              </a:rPr>
+              <a:t>github.com/uw-loci/qupath-extension-channel-names-viewer</a:t>
+            </a:r>
+            <a:endParaRPr lang="en-US" sz="750" dirty="0"/>
+          </a:p>
+        </p:txBody>
+      </p:sp>
+      <p:sp>
+        <p:nvSpPr>
+          <p:cNvPr id="13" name="Text 11"/>
+          <p:cNvSpPr/>
+          <p:nvPr/>
+        </p:nvSpPr>
+        <p:spPr>
+          <a:xfrm>
+            <a:off x="10140696" y="3986784"/>
+            <a:ext cx="1481328" cy="201168"/>
+          </a:xfrm>
+          <a:prstGeom prst="rect">
+            <a:avLst/>
+          </a:prstGeom>
+          <a:noFill/>
+          <a:ln/>
+        </p:spPr>
+        <p:txBody>
+          <a:bodyPr wrap="square" rtlCol="0" anchor="ctr"/>
+          <a:lstStyle/>
+          <a:p>
+            <a:pPr algn="ctr" indent="0" marL="0">
+              <a:buNone/>
+            </a:pPr>
+            <a:r>
+              <a:rPr lang="en-US" sz="1000" b="1" dirty="0">
+                <a:solidFill>
+                  <a:srgbClr val="1F4C86"/>
+                </a:solidFill>
+                <a:latin typeface="Calibri" pitchFamily="34" charset="0"/>
+                <a:ea typeface="Calibri" pitchFamily="34" charset="-122"/>
+                <a:cs typeface="Calibri" pitchFamily="34" charset="-120"/>
+              </a:rPr>
+              <a:t>Classify Subset</a:t>
+            </a:r>
+            <a:endParaRPr lang="en-US" sz="1000" dirty="0"/>
+          </a:p>
+        </p:txBody>
+      </p:sp>
+      <p:sp>
+        <p:nvSpPr>
+          <p:cNvPr id="14" name="Shape 12"/>
+          <p:cNvSpPr/>
+          <p:nvPr/>
+        </p:nvSpPr>
+        <p:spPr>
+          <a:xfrm>
+            <a:off x="10479024" y="4206240"/>
+            <a:ext cx="804672" cy="804672"/>
+          </a:xfrm>
+          <a:prstGeom prst="rect">
+            <a:avLst/>
+          </a:prstGeom>
+          <a:solidFill>
+            <a:srgbClr val="FFFFFF"/>
+          </a:solidFill>
+          <a:ln w="9525">
+            <a:solidFill>
+              <a:srgbClr val="3674C1"/>
+            </a:solidFill>
+            <a:prstDash val="dash"/>
+          </a:ln>
+        </p:spPr>
+      </p:sp>
+      <p:sp>
+        <p:nvSpPr>
+          <p:cNvPr id="15" name="Text 13"/>
+          <p:cNvSpPr/>
+          <p:nvPr/>
+        </p:nvSpPr>
+        <p:spPr>
+          <a:xfrm>
+            <a:off x="10479024" y="4206240"/>
+            <a:ext cx="804672" cy="804672"/>
+          </a:xfrm>
+          <a:prstGeom prst="rect">
+            <a:avLst/>
+          </a:prstGeom>
+          <a:noFill/>
+          <a:ln/>
+        </p:spPr>
+        <p:txBody>
+          <a:bodyPr wrap="square" rtlCol="0" anchor="ctr"/>
+          <a:lstStyle/>
+          <a:p>
+            <a:pPr algn="ctr" indent="0" marL="0">
+              <a:buNone/>
+            </a:pPr>
+            <a:r>
+              <a:rPr lang="en-US" sz="1100" dirty="0">
+                <a:solidFill>
+                  <a:srgbClr val="3674C1"/>
+                </a:solidFill>
+                <a:latin typeface="Calibri" pitchFamily="34" charset="0"/>
+                <a:ea typeface="Calibri" pitchFamily="34" charset="-122"/>
+                <a:cs typeface="Calibri" pitchFamily="34" charset="-120"/>
+              </a:rPr>
+              <a:t>QR</a:t>
+            </a:r>
+            <a:endParaRPr lang="en-US" sz="1100" dirty="0"/>
+          </a:p>
+        </p:txBody>
+      </p:sp>
+      <p:sp>
+        <p:nvSpPr>
+          <p:cNvPr id="16" name="Text 14">
+            <a:hlinkClick r:id="rId3" tooltip=""/>
+          </p:cNvPr>
+          <p:cNvSpPr/>
+          <p:nvPr/>
+        </p:nvSpPr>
+        <p:spPr>
+          <a:xfrm>
+            <a:off x="10140696" y="5047488"/>
+            <a:ext cx="1481328" cy="310896"/>
+          </a:xfrm>
+          <a:prstGeom prst="rect">
+            <a:avLst/>
+          </a:prstGeom>
+          <a:noFill/>
+          <a:ln/>
+        </p:spPr>
+        <p:txBody>
+          <a:bodyPr wrap="square" rtlCol="0" anchor="ctr"/>
+          <a:lstStyle/>
+          <a:p>
+            <a:pPr algn="ctr" indent="0" marL="0">
+              <a:buNone/>
+            </a:pPr>
+            <a:r>
+              <a:rPr lang="en-US" sz="750" u="sng" dirty="0">
+                <a:solidFill>
+                  <a:srgbClr val="5A6675"/>
+                </a:solidFill>
+                <a:latin typeface="Calibri" pitchFamily="34" charset="0"/>
+                <a:ea typeface="Calibri" pitchFamily="34" charset="-122"/>
+                <a:cs typeface="Calibri" pitchFamily="34" charset="-120"/>
+                <a:hlinkClick r:id="rId3" invalidUrl="" action="" tgtFrame="" tooltip="" history="1" highlightClick="0" endSnd="0">
+                  <a:extLst>
+                    <a:ext uri="{A12FA001-AC4F-418D-AE19-62706E023703}">
+                      <ahyp:hlinkClr xmlns:ahyp="http://schemas.microsoft.com/office/drawing/2018/hyperlinkcolor" val="tx"/>
+                    </a:ext>
+                  </a:extLst>
+                </a:hlinkClick>
+              </a:rPr>
+              <a:t>github.com/uw-loci/qupath-extension-classify-object-subset</a:t>
+            </a:r>
+            <a:endParaRPr lang="en-US" sz="750" dirty="0"/>
+          </a:p>
+        </p:txBody>
+      </p:sp>
+      <p:sp>
+        <p:nvSpPr>
+          <p:cNvPr id="17" name="Text 15"/>
+          <p:cNvSpPr/>
+          <p:nvPr/>
+        </p:nvSpPr>
+        <p:spPr>
+          <a:xfrm>
             <a:off x="640080" y="1755648"/>
-            <a:ext cx="10963656" cy="4279392"/>
+            <a:ext cx="9226296" cy="4279392"/>
           </a:xfrm>
           <a:prstGeom prst="rect">
             <a:avLst/>
@@ -19188,7 +21261,7 @@
       </p:sp>
       <p:sp>
         <p:nvSpPr>
-          <p:cNvPr id="6" name="Shape 4"/>
+          <p:cNvPr id="18" name="Shape 16"/>
           <p:cNvSpPr/>
           <p:nvPr/>
         </p:nvSpPr>
@@ -19213,7 +21286,7 @@
       </p:sp>
       <p:sp>
         <p:nvSpPr>
-          <p:cNvPr id="7" name="Text 5"/>
+          <p:cNvPr id="19" name="Text 17"/>
           <p:cNvSpPr/>
           <p:nvPr/>
         </p:nvSpPr>
@@ -19252,7 +21325,7 @@
       </p:sp>
       <p:sp>
         <p:nvSpPr>
-          <p:cNvPr id="8" name="Text 6"/>
+          <p:cNvPr id="20" name="Text 18"/>
           <p:cNvSpPr/>
           <p:nvPr/>
         </p:nvSpPr>
@@ -19427,8 +21500,310 @@
         </p:nvSpPr>
         <p:spPr>
           <a:xfrm>
+            <a:off x="10140696" y="1316736"/>
+            <a:ext cx="1481328" cy="201168"/>
+          </a:xfrm>
+          <a:prstGeom prst="rect">
+            <a:avLst/>
+          </a:prstGeom>
+          <a:noFill/>
+          <a:ln/>
+        </p:spPr>
+        <p:txBody>
+          <a:bodyPr wrap="square" rtlCol="0" anchor="ctr"/>
+          <a:lstStyle/>
+          <a:p>
+            <a:pPr algn="ctr" indent="0" marL="0">
+              <a:buNone/>
+            </a:pPr>
+            <a:r>
+              <a:rPr lang="en-US" sz="1000" b="1" dirty="0">
+                <a:solidFill>
+                  <a:srgbClr val="1F4C86"/>
+                </a:solidFill>
+                <a:latin typeface="Calibri" pitchFamily="34" charset="0"/>
+                <a:ea typeface="Calibri" pitchFamily="34" charset="-122"/>
+                <a:cs typeface="Calibri" pitchFamily="34" charset="-120"/>
+              </a:rPr>
+              <a:t>Wizard Wand</a:t>
+            </a:r>
+            <a:endParaRPr lang="en-US" sz="1000" dirty="0"/>
+          </a:p>
+        </p:txBody>
+      </p:sp>
+      <p:sp>
+        <p:nvSpPr>
+          <p:cNvPr id="6" name="Shape 4"/>
+          <p:cNvSpPr/>
+          <p:nvPr/>
+        </p:nvSpPr>
+        <p:spPr>
+          <a:xfrm>
+            <a:off x="10355580" y="1536192"/>
+            <a:ext cx="1051560" cy="1051560"/>
+          </a:xfrm>
+          <a:prstGeom prst="rect">
+            <a:avLst/>
+          </a:prstGeom>
+          <a:solidFill>
+            <a:srgbClr val="FFFFFF"/>
+          </a:solidFill>
+          <a:ln w="9525">
+            <a:solidFill>
+              <a:srgbClr val="3674C1"/>
+            </a:solidFill>
+            <a:prstDash val="dash"/>
+          </a:ln>
+        </p:spPr>
+      </p:sp>
+      <p:sp>
+        <p:nvSpPr>
+          <p:cNvPr id="7" name="Text 5"/>
+          <p:cNvSpPr/>
+          <p:nvPr/>
+        </p:nvSpPr>
+        <p:spPr>
+          <a:xfrm>
+            <a:off x="10355580" y="1536192"/>
+            <a:ext cx="1051560" cy="1051560"/>
+          </a:xfrm>
+          <a:prstGeom prst="rect">
+            <a:avLst/>
+          </a:prstGeom>
+          <a:noFill/>
+          <a:ln/>
+        </p:spPr>
+        <p:txBody>
+          <a:bodyPr wrap="square" rtlCol="0" anchor="ctr"/>
+          <a:lstStyle/>
+          <a:p>
+            <a:pPr algn="ctr" indent="0" marL="0">
+              <a:buNone/>
+            </a:pPr>
+            <a:r>
+              <a:rPr lang="en-US" sz="1100" dirty="0">
+                <a:solidFill>
+                  <a:srgbClr val="3674C1"/>
+                </a:solidFill>
+                <a:latin typeface="Calibri" pitchFamily="34" charset="0"/>
+                <a:ea typeface="Calibri" pitchFamily="34" charset="-122"/>
+                <a:cs typeface="Calibri" pitchFamily="34" charset="-120"/>
+              </a:rPr>
+              <a:t>QR</a:t>
+            </a:r>
+            <a:endParaRPr lang="en-US" sz="1100" dirty="0"/>
+          </a:p>
+        </p:txBody>
+      </p:sp>
+      <p:sp>
+        <p:nvSpPr>
+          <p:cNvPr id="8" name="Text 6">
+            <a:hlinkClick r:id="rId1" tooltip=""/>
+          </p:cNvPr>
+          <p:cNvSpPr/>
+          <p:nvPr/>
+        </p:nvSpPr>
+        <p:spPr>
+          <a:xfrm>
+            <a:off x="10140696" y="2624328"/>
+            <a:ext cx="1481328" cy="310896"/>
+          </a:xfrm>
+          <a:prstGeom prst="rect">
+            <a:avLst/>
+          </a:prstGeom>
+          <a:noFill/>
+          <a:ln/>
+        </p:spPr>
+        <p:txBody>
+          <a:bodyPr wrap="square" rtlCol="0" anchor="ctr"/>
+          <a:lstStyle/>
+          <a:p>
+            <a:pPr algn="ctr" indent="0" marL="0">
+              <a:buNone/>
+            </a:pPr>
+            <a:r>
+              <a:rPr lang="en-US" sz="750" u="sng" dirty="0">
+                <a:solidFill>
+                  <a:srgbClr val="5A6675"/>
+                </a:solidFill>
+                <a:latin typeface="Calibri" pitchFamily="34" charset="0"/>
+                <a:ea typeface="Calibri" pitchFamily="34" charset="-122"/>
+                <a:cs typeface="Calibri" pitchFamily="34" charset="-120"/>
+                <a:hlinkClick r:id="rId1" invalidUrl="" action="" tgtFrame="" tooltip="" history="1" highlightClick="0" endSnd="0">
+                  <a:extLst>
+                    <a:ext uri="{A12FA001-AC4F-418D-AE19-62706E023703}">
+                      <ahyp:hlinkClr xmlns:ahyp="http://schemas.microsoft.com/office/drawing/2018/hyperlinkcolor" val="tx"/>
+                    </a:ext>
+                  </a:extLst>
+                </a:hlinkClick>
+              </a:rPr>
+              <a:t>github.com/uw-loci/qupath-extension-wizard-wand</a:t>
+            </a:r>
+            <a:endParaRPr lang="en-US" sz="750" dirty="0"/>
+          </a:p>
+        </p:txBody>
+      </p:sp>
+      <p:sp>
+        <p:nvSpPr>
+          <p:cNvPr id="9" name="Text 7"/>
+          <p:cNvSpPr/>
+          <p:nvPr/>
+        </p:nvSpPr>
+        <p:spPr>
+          <a:xfrm>
+            <a:off x="10140696" y="2971800"/>
+            <a:ext cx="1481328" cy="201168"/>
+          </a:xfrm>
+          <a:prstGeom prst="rect">
+            <a:avLst/>
+          </a:prstGeom>
+          <a:noFill/>
+          <a:ln/>
+        </p:spPr>
+        <p:txBody>
+          <a:bodyPr wrap="square" rtlCol="0" anchor="ctr"/>
+          <a:lstStyle/>
+          <a:p>
+            <a:pPr algn="ctr" indent="0" marL="0">
+              <a:buNone/>
+            </a:pPr>
+            <a:r>
+              <a:rPr lang="en-US" sz="1000" b="1" dirty="0">
+                <a:solidFill>
+                  <a:srgbClr val="1F4C86"/>
+                </a:solidFill>
+                <a:latin typeface="Calibri" pitchFamily="34" charset="0"/>
+                <a:ea typeface="Calibri" pitchFamily="34" charset="-122"/>
+                <a:cs typeface="Calibri" pitchFamily="34" charset="-120"/>
+              </a:rPr>
+              <a:t>Polyline Wand</a:t>
+            </a:r>
+            <a:endParaRPr lang="en-US" sz="1000" dirty="0"/>
+          </a:p>
+        </p:txBody>
+      </p:sp>
+      <p:sp>
+        <p:nvSpPr>
+          <p:cNvPr id="10" name="Shape 8"/>
+          <p:cNvSpPr/>
+          <p:nvPr/>
+        </p:nvSpPr>
+        <p:spPr>
+          <a:xfrm>
+            <a:off x="10355580" y="3191256"/>
+            <a:ext cx="1051560" cy="1051560"/>
+          </a:xfrm>
+          <a:prstGeom prst="rect">
+            <a:avLst/>
+          </a:prstGeom>
+          <a:solidFill>
+            <a:srgbClr val="FFFFFF"/>
+          </a:solidFill>
+          <a:ln w="9525">
+            <a:solidFill>
+              <a:srgbClr val="3674C1"/>
+            </a:solidFill>
+            <a:prstDash val="dash"/>
+          </a:ln>
+        </p:spPr>
+      </p:sp>
+      <p:sp>
+        <p:nvSpPr>
+          <p:cNvPr id="11" name="Text 9"/>
+          <p:cNvSpPr/>
+          <p:nvPr/>
+        </p:nvSpPr>
+        <p:spPr>
+          <a:xfrm>
+            <a:off x="10355580" y="3191256"/>
+            <a:ext cx="1051560" cy="1051560"/>
+          </a:xfrm>
+          <a:prstGeom prst="rect">
+            <a:avLst/>
+          </a:prstGeom>
+          <a:noFill/>
+          <a:ln/>
+        </p:spPr>
+        <p:txBody>
+          <a:bodyPr wrap="square" rtlCol="0" anchor="ctr"/>
+          <a:lstStyle/>
+          <a:p>
+            <a:pPr algn="ctr" indent="0" marL="0">
+              <a:buNone/>
+            </a:pPr>
+            <a:r>
+              <a:rPr lang="en-US" sz="1100" dirty="0">
+                <a:solidFill>
+                  <a:srgbClr val="3674C1"/>
+                </a:solidFill>
+                <a:latin typeface="Calibri" pitchFamily="34" charset="0"/>
+                <a:ea typeface="Calibri" pitchFamily="34" charset="-122"/>
+                <a:cs typeface="Calibri" pitchFamily="34" charset="-120"/>
+              </a:rPr>
+              <a:t>QR</a:t>
+            </a:r>
+            <a:endParaRPr lang="en-US" sz="1100" dirty="0"/>
+          </a:p>
+        </p:txBody>
+      </p:sp>
+      <p:sp>
+        <p:nvSpPr>
+          <p:cNvPr id="12" name="Text 10">
+            <a:hlinkClick r:id="rId2" tooltip=""/>
+          </p:cNvPr>
+          <p:cNvSpPr/>
+          <p:nvPr/>
+        </p:nvSpPr>
+        <p:spPr>
+          <a:xfrm>
+            <a:off x="10140696" y="4279392"/>
+            <a:ext cx="1481328" cy="310896"/>
+          </a:xfrm>
+          <a:prstGeom prst="rect">
+            <a:avLst/>
+          </a:prstGeom>
+          <a:noFill/>
+          <a:ln/>
+        </p:spPr>
+        <p:txBody>
+          <a:bodyPr wrap="square" rtlCol="0" anchor="ctr"/>
+          <a:lstStyle/>
+          <a:p>
+            <a:pPr algn="ctr" indent="0" marL="0">
+              <a:buNone/>
+            </a:pPr>
+            <a:r>
+              <a:rPr lang="en-US" sz="750" u="sng" dirty="0">
+                <a:solidFill>
+                  <a:srgbClr val="5A6675"/>
+                </a:solidFill>
+                <a:latin typeface="Calibri" pitchFamily="34" charset="0"/>
+                <a:ea typeface="Calibri" pitchFamily="34" charset="-122"/>
+                <a:cs typeface="Calibri" pitchFamily="34" charset="-120"/>
+                <a:hlinkClick r:id="rId2" invalidUrl="" action="" tgtFrame="" tooltip="" history="1" highlightClick="0" endSnd="0">
+                  <a:extLst>
+                    <a:ext uri="{A12FA001-AC4F-418D-AE19-62706E023703}">
+                      <ahyp:hlinkClr xmlns:ahyp="http://schemas.microsoft.com/office/drawing/2018/hyperlinkcolor" val="tx"/>
+                    </a:ext>
+                  </a:extLst>
+                </a:hlinkClick>
+              </a:rPr>
+              <a:t>github.com/uw-loci/qupath-extension-polyline-wand</a:t>
+            </a:r>
+            <a:endParaRPr lang="en-US" sz="750" dirty="0"/>
+          </a:p>
+        </p:txBody>
+      </p:sp>
+      <p:sp>
+        <p:nvSpPr>
+          <p:cNvPr id="13" name="Text 11"/>
+          <p:cNvSpPr/>
+          <p:nvPr/>
+        </p:nvSpPr>
+        <p:spPr>
+          <a:xfrm>
             <a:off x="640080" y="1755648"/>
-            <a:ext cx="10963656" cy="4279392"/>
+            <a:ext cx="9226296" cy="4279392"/>
           </a:xfrm>
           <a:prstGeom prst="rect">
             <a:avLst/>
@@ -19563,7 +21938,7 @@
       </p:sp>
       <p:sp>
         <p:nvSpPr>
-          <p:cNvPr id="6" name="Shape 4"/>
+          <p:cNvPr id="14" name="Shape 12"/>
           <p:cNvSpPr/>
           <p:nvPr/>
         </p:nvSpPr>
@@ -19588,7 +21963,7 @@
       </p:sp>
       <p:sp>
         <p:nvSpPr>
-          <p:cNvPr id="7" name="Text 5"/>
+          <p:cNvPr id="15" name="Text 13"/>
           <p:cNvSpPr/>
           <p:nvPr/>
         </p:nvSpPr>
@@ -19627,7 +22002,7 @@
       </p:sp>
       <p:sp>
         <p:nvSpPr>
-          <p:cNvPr id="8" name="Text 6"/>
+          <p:cNvPr id="16" name="Text 14"/>
           <p:cNvSpPr/>
           <p:nvPr/>
         </p:nvSpPr>

</xml_diff>